<commit_message>
Expand presentation with README slides
</commit_message>
<xml_diff>
--- a/outputs/bank_roi_presentation_ru.pptx
+++ b/outputs/bank_roi_presentation_ru.pptx
@@ -2,14 +2,16 @@
 <file path=ppt/presentation.xml><?xml version="1.0" encoding="utf-8"?>
 <p:presentation xmlns:p="http://schemas.openxmlformats.org/presentationml/2006/main">
   <p:sldMasterIdLst>
-    <p:sldMasterId xmlns:r="http://schemas.openxmlformats.org/officeDocument/2006/relationships" id="2147483648" r:id="Rf5edfdf9692244d3"/>
+    <p:sldMasterId xmlns:r="http://schemas.openxmlformats.org/officeDocument/2006/relationships" id="2147483648" r:id="Redd06cf0fe3e48d1"/>
   </p:sldMasterIdLst>
   <p:notesMasterIdLst>
-    <p:notesMasterId xmlns:r="http://schemas.openxmlformats.org/officeDocument/2006/relationships" r:id="R4e0ac66e7c3d4ac3"/>
+    <p:notesMasterId xmlns:r="http://schemas.openxmlformats.org/officeDocument/2006/relationships" r:id="R916098676ba1429c"/>
   </p:notesMasterIdLst>
   <p:sldIdLst>
-    <p:sldId xmlns:r="http://schemas.openxmlformats.org/officeDocument/2006/relationships" id="256" r:id="R7ce4a22cde524132"/>
-    <p:sldId xmlns:r="http://schemas.openxmlformats.org/officeDocument/2006/relationships" id="257" r:id="R2ecf7c8671c94e5d"/>
+    <p:sldId xmlns:r="http://schemas.openxmlformats.org/officeDocument/2006/relationships" id="256" r:id="R631839c1024e4a75"/>
+    <p:sldId xmlns:r="http://schemas.openxmlformats.org/officeDocument/2006/relationships" id="257" r:id="Ra9d6a4e8d24142a5"/>
+    <p:sldId xmlns:r="http://schemas.openxmlformats.org/officeDocument/2006/relationships" id="258" r:id="Re7d8b66d6cb64c2f"/>
+    <p:sldId xmlns:r="http://schemas.openxmlformats.org/officeDocument/2006/relationships" id="259" r:id="Rbfc57193ed214d11"/>
   </p:sldIdLst>
   <p:sldSz cx="12192000" cy="6858000"/>
   <p:notesSz cx="6858000" cy="9144000"/>
@@ -583,6 +585,191 @@
 </p:notes>
 </file>
 
+<file path=ppt/notesSlides/notesSlide3.xml><?xml version="1.0" encoding="utf-8"?>
+<p:notes xmlns:p="http://schemas.openxmlformats.org/presentationml/2006/main">
+  <p:cSld>
+    <p:spTree>
+      <p:nvGrpSpPr>
+        <p:cNvPr id="1" name=""/>
+        <p:cNvGrpSpPr/>
+        <p:nvPr/>
+      </p:nvGrpSpPr>
+      <p:grpSpPr>
+        <a:xfrm xmlns:a="http://schemas.openxmlformats.org/drawingml/2006/main"/>
+      </p:grpSpPr>
+      <p:sp>
+        <p:nvSpPr>
+          <p:cNvPr id="2" name="Slide Image Placeholder 1"/>
+          <p:cNvSpPr>
+            <a:spLocks xmlns:a="http://schemas.openxmlformats.org/drawingml/2006/main" noGrp="1"/>
+          </p:cNvSpPr>
+          <p:nvPr>
+            <p:ph type="sldImg" idx="0"/>
+          </p:nvPr>
+        </p:nvSpPr>
+        <p:spPr/>
+      </p:sp>
+      <p:sp>
+        <p:nvSpPr>
+          <p:cNvPr id="3" name="Notes Placeholder 2"/>
+          <p:cNvSpPr>
+            <a:spLocks xmlns:a="http://schemas.openxmlformats.org/drawingml/2006/main" noGrp="1"/>
+          </p:cNvSpPr>
+          <p:nvPr>
+            <p:ph type="body" idx="1"/>
+          </p:nvPr>
+        </p:nvSpPr>
+        <p:spPr/>
+        <p:txBody>
+          <a:bodyPr xmlns:a="http://schemas.openxmlformats.org/drawingml/2006/main"/>
+          <a:lstStyle xmlns:a="http://schemas.openxmlformats.org/drawingml/2006/main"/>
+          <a:p xmlns:a="http://schemas.openxmlformats.org/drawingml/2006/main">
+            <a:r>
+              <a:t>[Sources]</a:t>
+            </a:r>
+          </a:p>
+          <a:p xmlns:a="http://schemas.openxmlformats.org/drawingml/2006/main">
+            <a:r>
+              <a:t>- /Users/alexandra/Documents/Codex/2026-08-09/yt/README.md</a:t>
+            </a:r>
+          </a:p>
+          <a:p xmlns:a="http://schemas.openxmlformats.org/drawingml/2006/main">
+            <a:r>
+              <a:t>- /Users/alexandra/Documents/Codex/2026-08-09/yt/data/processed/tableau_tenure_curve.csv</a:t>
+            </a:r>
+          </a:p>
+          <a:p xmlns:a="http://schemas.openxmlformats.org/drawingml/2006/main">
+            <a:r>
+              <a:t>- https://github.com/alexsoldatova/bank-roi-tableau-dashboard</a:t>
+            </a:r>
+          </a:p>
+          <a:p xmlns:a="http://schemas.openxmlformats.org/drawingml/2006/main">
+            <a:r>
+              <a:t>[/Sources]</a:t>
+            </a:r>
+          </a:p>
+        </p:txBody>
+      </p:sp>
+      <p:sp>
+        <p:nvSpPr>
+          <p:cNvPr id="4" name="Slide Number Placeholder 3"/>
+          <p:cNvSpPr>
+            <a:spLocks xmlns:a="http://schemas.openxmlformats.org/drawingml/2006/main" noGrp="1"/>
+          </p:cNvSpPr>
+          <p:nvPr>
+            <p:ph type="sldNum" idx="5"/>
+          </p:nvPr>
+        </p:nvSpPr>
+        <p:spPr/>
+        <p:txBody>
+          <a:bodyPr xmlns:a="http://schemas.openxmlformats.org/drawingml/2006/main"/>
+          <a:lstStyle xmlns:a="http://schemas.openxmlformats.org/drawingml/2006/main"/>
+          <a:p xmlns:a="http://schemas.openxmlformats.org/drawingml/2006/main"/>
+        </p:txBody>
+      </p:sp>
+    </p:spTree>
+  </p:cSld>
+  <p:clrMapOvr>
+    <a:masterClrMapping xmlns:a="http://schemas.openxmlformats.org/drawingml/2006/main"/>
+  </p:clrMapOvr>
+</p:notes>
+</file>
+
+<file path=ppt/notesSlides/notesSlide4.xml><?xml version="1.0" encoding="utf-8"?>
+<p:notes xmlns:p="http://schemas.openxmlformats.org/presentationml/2006/main">
+  <p:cSld>
+    <p:spTree>
+      <p:nvGrpSpPr>
+        <p:cNvPr id="1" name=""/>
+        <p:cNvGrpSpPr/>
+        <p:nvPr/>
+      </p:nvGrpSpPr>
+      <p:grpSpPr>
+        <a:xfrm xmlns:a="http://schemas.openxmlformats.org/drawingml/2006/main"/>
+      </p:grpSpPr>
+      <p:sp>
+        <p:nvSpPr>
+          <p:cNvPr id="2" name="Slide Image Placeholder 1"/>
+          <p:cNvSpPr>
+            <a:spLocks xmlns:a="http://schemas.openxmlformats.org/drawingml/2006/main" noGrp="1"/>
+          </p:cNvSpPr>
+          <p:nvPr>
+            <p:ph type="sldImg" idx="0"/>
+          </p:nvPr>
+        </p:nvSpPr>
+        <p:spPr/>
+      </p:sp>
+      <p:sp>
+        <p:nvSpPr>
+          <p:cNvPr id="3" name="Notes Placeholder 2"/>
+          <p:cNvSpPr>
+            <a:spLocks xmlns:a="http://schemas.openxmlformats.org/drawingml/2006/main" noGrp="1"/>
+          </p:cNvSpPr>
+          <p:nvPr>
+            <p:ph type="body" idx="1"/>
+          </p:nvPr>
+        </p:nvSpPr>
+        <p:spPr/>
+        <p:txBody>
+          <a:bodyPr xmlns:a="http://schemas.openxmlformats.org/drawingml/2006/main"/>
+          <a:lstStyle xmlns:a="http://schemas.openxmlformats.org/drawingml/2006/main"/>
+          <a:p xmlns:a="http://schemas.openxmlformats.org/drawingml/2006/main">
+            <a:r>
+              <a:t>[Sources]</a:t>
+            </a:r>
+          </a:p>
+          <a:p xmlns:a="http://schemas.openxmlformats.org/drawingml/2006/main">
+            <a:r>
+              <a:t>- /Users/alexandra/Documents/Codex/2026-08-09/yt/README.md</a:t>
+            </a:r>
+          </a:p>
+          <a:p xmlns:a="http://schemas.openxmlformats.org/drawingml/2006/main">
+            <a:r>
+              <a:t>- /Users/alexandra/Documents/Codex/2026-08-09/yt/config/assumptions.json</a:t>
+            </a:r>
+          </a:p>
+          <a:p xmlns:a="http://schemas.openxmlformats.org/drawingml/2006/main">
+            <a:r>
+              <a:t>- /Users/alexandra/Documents/Codex/2026-08-09/yt/tests</a:t>
+            </a:r>
+          </a:p>
+          <a:p xmlns:a="http://schemas.openxmlformats.org/drawingml/2006/main">
+            <a:r>
+              <a:t>- https://github.com/alexsoldatova/bank-roi-tableau-dashboard</a:t>
+            </a:r>
+          </a:p>
+          <a:p xmlns:a="http://schemas.openxmlformats.org/drawingml/2006/main">
+            <a:r>
+              <a:t>[/Sources]</a:t>
+            </a:r>
+          </a:p>
+        </p:txBody>
+      </p:sp>
+      <p:sp>
+        <p:nvSpPr>
+          <p:cNvPr id="4" name="Slide Number Placeholder 3"/>
+          <p:cNvSpPr>
+            <a:spLocks xmlns:a="http://schemas.openxmlformats.org/drawingml/2006/main" noGrp="1"/>
+          </p:cNvSpPr>
+          <p:nvPr>
+            <p:ph type="sldNum" idx="5"/>
+          </p:nvPr>
+        </p:nvSpPr>
+        <p:spPr/>
+        <p:txBody>
+          <a:bodyPr xmlns:a="http://schemas.openxmlformats.org/drawingml/2006/main"/>
+          <a:lstStyle xmlns:a="http://schemas.openxmlformats.org/drawingml/2006/main"/>
+          <a:p xmlns:a="http://schemas.openxmlformats.org/drawingml/2006/main"/>
+        </p:txBody>
+      </p:sp>
+    </p:spTree>
+  </p:cSld>
+  <p:clrMapOvr>
+    <a:masterClrMapping xmlns:a="http://schemas.openxmlformats.org/drawingml/2006/main"/>
+  </p:clrMapOvr>
+</p:notes>
+</file>
+
 <file path=ppt/slideLayouts/slideLayout1.xml><?xml version="1.0" encoding="utf-8"?>
 <p:sldLayout xmlns:p="http://schemas.openxmlformats.org/presentationml/2006/main" type="title">
   <p:cSld name="Title Slide">
@@ -621,7 +808,7 @@
   </p:cSld>
   <p:clrMap bg1="lt1" tx1="dk1" bg2="lt2" tx2="dk2" accent1="accent1" accent2="accent2" accent3="accent3" accent4="accent4" accent5="accent5" accent6="accent6" hlink="hlink" folHlink="folHlink"/>
   <p:sldLayoutIdLst>
-    <p:sldLayoutId xmlns:r="http://schemas.openxmlformats.org/officeDocument/2006/relationships" id="2147483649" r:id="R35ea1f3c62aa4345"/>
+    <p:sldLayoutId xmlns:r="http://schemas.openxmlformats.org/officeDocument/2006/relationships" id="2147483649" r:id="R359ff6d82ddb4368"/>
   </p:sldLayoutIdLst>
   <p:txStyles>
     <p:titleStyle>
@@ -1155,6 +1342,7 @@
     <c:plotArea>
       <c:lineChart>
         <c:grouping val="standard"/>
+        <c:varyColors val="0"/>
         <c:ser>
           <c:idx val="0"/>
           <c:order val="0"/>
@@ -1765,6 +1953,484 @@
 </c:chartSpace>
 </file>
 
+<file path=ppt/slides/charts/chart3.xml><?xml version="1.0" encoding="utf-8"?>
+<c:chartSpace xmlns:c="http://schemas.openxmlformats.org/drawingml/2006/chart">
+  <c:lang val="en-US"/>
+  <c:chart>
+    <c:plotArea>
+      <c:barChart>
+        <c:barDir val="col"/>
+        <c:grouping val="clustered"/>
+        <c:varyColors val="0"/>
+        <c:ser>
+          <c:idx val="0"/>
+          <c:order val="0"/>
+          <c:tx>
+            <c:v>Счёт открыт</c:v>
+          </c:tx>
+          <c:spPr>
+            <a:solidFill xmlns:a="http://schemas.openxmlformats.org/drawingml/2006/main">
+              <a:srgbClr val="D0EDFA"/>
+            </a:solidFill>
+          </c:spPr>
+          <c:cat>
+            <c:strLit>
+              <c:ptCount val="6"/>
+              <c:pt idx="0">
+                <c:v>0 мес.</c:v>
+              </c:pt>
+              <c:pt idx="1">
+                <c:v>6 мес.</c:v>
+              </c:pt>
+              <c:pt idx="2">
+                <c:v>12 мес.</c:v>
+              </c:pt>
+              <c:pt idx="3">
+                <c:v>18 мес.</c:v>
+              </c:pt>
+              <c:pt idx="4">
+                <c:v>24 мес.</c:v>
+              </c:pt>
+              <c:pt idx="5">
+                <c:v>28 мес.</c:v>
+              </c:pt>
+            </c:strLit>
+          </c:cat>
+          <c:val>
+            <c:numLit>
+              <c:formatCode>0</c:formatCode>
+              <c:ptCount val="6"/>
+              <c:pt idx="0">
+                <c:v>1</c:v>
+              </c:pt>
+              <c:pt idx="1">
+                <c:v>0.8831728966120765</c:v>
+              </c:pt>
+              <c:pt idx="2">
+                <c:v>0.7989358963357075</c:v>
+              </c:pt>
+              <c:pt idx="3">
+                <c:v>0.7221917808219178</c:v>
+              </c:pt>
+              <c:pt idx="4">
+                <c:v>0.6524547803617571</c:v>
+              </c:pt>
+              <c:pt idx="5">
+                <c:v>0.6548323471400395</c:v>
+              </c:pt>
+            </c:numLit>
+          </c:val>
+        </c:ser>
+        <c:ser>
+          <c:idx val="1"/>
+          <c:order val="1"/>
+          <c:tx>
+            <c:v>Счёт активен</c:v>
+          </c:tx>
+          <c:spPr>
+            <a:solidFill xmlns:a="http://schemas.openxmlformats.org/drawingml/2006/main">
+              <a:srgbClr val="3D8DFF"/>
+            </a:solidFill>
+          </c:spPr>
+          <c:cat>
+            <c:strLit>
+              <c:ptCount val="6"/>
+              <c:pt idx="0">
+                <c:v>0 мес.</c:v>
+              </c:pt>
+              <c:pt idx="1">
+                <c:v>6 мес.</c:v>
+              </c:pt>
+              <c:pt idx="2">
+                <c:v>12 мес.</c:v>
+              </c:pt>
+              <c:pt idx="3">
+                <c:v>18 мес.</c:v>
+              </c:pt>
+              <c:pt idx="4">
+                <c:v>24 мес.</c:v>
+              </c:pt>
+              <c:pt idx="5">
+                <c:v>28 мес.</c:v>
+              </c:pt>
+            </c:strLit>
+          </c:cat>
+          <c:val>
+            <c:numLit>
+              <c:formatCode>0</c:formatCode>
+              <c:ptCount val="6"/>
+              <c:pt idx="0">
+                <c:v>0.5658136645962732</c:v>
+              </c:pt>
+              <c:pt idx="1">
+                <c:v>0.5957619702462807</c:v>
+              </c:pt>
+              <c:pt idx="2">
+                <c:v>0.5270745730713121</c:v>
+              </c:pt>
+              <c:pt idx="3">
+                <c:v>0.4626027397260274</c:v>
+              </c:pt>
+              <c:pt idx="4">
+                <c:v>0.3875968992248062</c:v>
+              </c:pt>
+              <c:pt idx="5">
+                <c:v>0.41222879684418146</c:v>
+              </c:pt>
+            </c:numLit>
+          </c:val>
+        </c:ser>
+        <c:dLbls>
+          <c:showLegendKey val="0"/>
+          <c:showVal val="0"/>
+          <c:showCatName val="0"/>
+          <c:showSerName val="0"/>
+          <c:showPercent val="0"/>
+          <c:showBubbleSize val="0"/>
+          <c:showLeaderLines val="0"/>
+        </c:dLbls>
+        <c:gapWidth val="80"/>
+        <c:axId val="48650112"/>
+        <c:axId val="48672768"/>
+      </c:barChart>
+      <c:catAx>
+        <c:axId val="48650112"/>
+        <c:scaling>
+          <c:orientation val="minMax"/>
+        </c:scaling>
+        <c:delete val="0"/>
+        <c:axPos val="b"/>
+        <c:numFmt formatCode="General"/>
+        <c:majorTickMark val="none"/>
+        <c:minorTickMark val="none"/>
+        <c:spPr>
+          <a:ln xmlns:a="http://schemas.openxmlformats.org/drawingml/2006/main" w="9525">
+            <a:solidFill>
+              <a:srgbClr val="B8BCC4"/>
+            </a:solidFill>
+            <a:prstDash val="solid"/>
+          </a:ln>
+        </c:spPr>
+        <c:txPr>
+          <a:bodyPr xmlns:a="http://schemas.openxmlformats.org/drawingml/2006/main" anchorCtr="1"/>
+          <a:lstStyle xmlns:a="http://schemas.openxmlformats.org/drawingml/2006/main"/>
+          <a:p xmlns:a="http://schemas.openxmlformats.org/drawingml/2006/main">
+            <a:pPr>
+              <a:defRPr sz="825">
+                <a:solidFill>
+                  <a:srgbClr val="333333"/>
+                </a:solidFill>
+              </a:defRPr>
+            </a:pPr>
+          </a:p>
+        </c:txPr>
+        <c:crossAx val="48672768"/>
+      </c:catAx>
+      <c:valAx>
+        <c:axId val="48672768"/>
+        <c:scaling>
+          <c:orientation val="minMax"/>
+          <c:max val="1"/>
+          <c:min val="0"/>
+        </c:scaling>
+        <c:delete val="0"/>
+        <c:axPos val="l"/>
+        <c:majorGridlines>
+          <c:spPr>
+            <a:ln xmlns:a="http://schemas.openxmlformats.org/drawingml/2006/main" w="9525">
+              <a:solidFill>
+                <a:srgbClr val="EDEDED"/>
+              </a:solidFill>
+              <a:prstDash val="solid"/>
+            </a:ln>
+          </c:spPr>
+        </c:majorGridlines>
+        <c:numFmt formatCode="0%"/>
+        <c:majorTickMark val="none"/>
+        <c:minorTickMark val="none"/>
+        <c:spPr>
+          <a:ln xmlns:a="http://schemas.openxmlformats.org/drawingml/2006/main" w="0">
+            <a:solidFill>
+              <a:srgbClr val="FFFFFF"/>
+            </a:solidFill>
+            <a:prstDash val="solid"/>
+          </a:ln>
+        </c:spPr>
+        <c:txPr>
+          <a:bodyPr xmlns:a="http://schemas.openxmlformats.org/drawingml/2006/main" anchorCtr="1"/>
+          <a:lstStyle xmlns:a="http://schemas.openxmlformats.org/drawingml/2006/main"/>
+          <a:p xmlns:a="http://schemas.openxmlformats.org/drawingml/2006/main">
+            <a:pPr>
+              <a:defRPr sz="825">
+                <a:solidFill>
+                  <a:srgbClr val="333333"/>
+                </a:solidFill>
+              </a:defRPr>
+            </a:pPr>
+          </a:p>
+        </c:txPr>
+        <c:crossAx val="48650112"/>
+        <c:crossBetween val="between"/>
+        <c:majorUnit val="0.2"/>
+      </c:valAx>
+      <c:spPr>
+        <a:noFill xmlns:a="http://schemas.openxmlformats.org/drawingml/2006/main"/>
+        <a:ln xmlns:a="http://schemas.openxmlformats.org/drawingml/2006/main" w="0">
+          <a:solidFill>
+            <a:srgbClr val="FFFFFF"/>
+          </a:solidFill>
+          <a:prstDash val="solid"/>
+        </a:ln>
+      </c:spPr>
+    </c:plotArea>
+    <c:legend>
+      <c:legendPos val="b"/>
+      <c:overlay val="0"/>
+      <c:txPr>
+        <a:bodyPr xmlns:a="http://schemas.openxmlformats.org/drawingml/2006/main" anchorCtr="1"/>
+        <a:lstStyle xmlns:a="http://schemas.openxmlformats.org/drawingml/2006/main"/>
+        <a:p xmlns:a="http://schemas.openxmlformats.org/drawingml/2006/main">
+          <a:pPr>
+            <a:defRPr sz="900">
+              <a:solidFill>
+                <a:srgbClr val="333333"/>
+              </a:solidFill>
+            </a:defRPr>
+          </a:pPr>
+        </a:p>
+      </c:txPr>
+    </c:legend>
+    <c:plotVisOnly val="1"/>
+  </c:chart>
+  <c:spPr>
+    <a:solidFill xmlns:a="http://schemas.openxmlformats.org/drawingml/2006/main">
+      <a:srgbClr val="FFFFFF"/>
+    </a:solidFill>
+    <a:ln xmlns:a="http://schemas.openxmlformats.org/drawingml/2006/main" w="0">
+      <a:solidFill>
+        <a:srgbClr val="FFFFFF"/>
+      </a:solidFill>
+      <a:prstDash val="solid"/>
+    </a:ln>
+  </c:spPr>
+</c:chartSpace>
+</file>
+
+<file path=ppt/slides/charts/chart4.xml><?xml version="1.0" encoding="utf-8"?>
+<c:chartSpace xmlns:c="http://schemas.openxmlformats.org/drawingml/2006/chart">
+  <c:lang val="en-US"/>
+  <c:chart>
+    <c:plotArea>
+      <c:barChart>
+        <c:barDir val="col"/>
+        <c:grouping val="clustered"/>
+        <c:varyColors val="0"/>
+        <c:ser>
+          <c:idx val="0"/>
+          <c:order val="0"/>
+          <c:tx>
+            <c:v>Ожидаемые месяцы</c:v>
+          </c:tx>
+          <c:spPr>
+            <a:solidFill xmlns:a="http://schemas.openxmlformats.org/drawingml/2006/main">
+              <a:srgbClr val="D0EDFA"/>
+            </a:solidFill>
+          </c:spPr>
+          <c:cat>
+            <c:strLit>
+              <c:ptCount val="2"/>
+              <c:pt idx="0">
+                <c:v>Активные</c:v>
+              </c:pt>
+              <c:pt idx="1">
+                <c:v>Открытые</c:v>
+              </c:pt>
+            </c:strLit>
+          </c:cat>
+          <c:val>
+            <c:numLit>
+              <c:formatCode>0.0</c:formatCode>
+              <c:ptCount val="2"/>
+              <c:pt idx="0">
+                <c:v>14.7342</c:v>
+              </c:pt>
+              <c:pt idx="1">
+                <c:v>22.7496</c:v>
+              </c:pt>
+            </c:numLit>
+          </c:val>
+        </c:ser>
+        <c:ser>
+          <c:idx val="1"/>
+          <c:order val="1"/>
+          <c:tx>
+            <c:v>Предел наблюдения</c:v>
+          </c:tx>
+          <c:spPr>
+            <a:solidFill xmlns:a="http://schemas.openxmlformats.org/drawingml/2006/main">
+              <a:srgbClr val="3D8DFF"/>
+            </a:solidFill>
+          </c:spPr>
+          <c:cat>
+            <c:strLit>
+              <c:ptCount val="2"/>
+              <c:pt idx="0">
+                <c:v>Активные</c:v>
+              </c:pt>
+              <c:pt idx="1">
+                <c:v>Открытые</c:v>
+              </c:pt>
+            </c:strLit>
+          </c:cat>
+          <c:val>
+            <c:numLit>
+              <c:formatCode>0.0</c:formatCode>
+              <c:ptCount val="2"/>
+              <c:pt idx="0">
+                <c:v>29</c:v>
+              </c:pt>
+              <c:pt idx="1">
+                <c:v>29</c:v>
+              </c:pt>
+            </c:numLit>
+          </c:val>
+        </c:ser>
+        <c:dLbls>
+          <c:showLegendKey val="0"/>
+          <c:showVal val="1"/>
+          <c:showCatName val="0"/>
+          <c:showSerName val="0"/>
+          <c:showPercent val="0"/>
+          <c:showBubbleSize val="0"/>
+          <c:showLeaderLines val="0"/>
+        </c:dLbls>
+        <c:gapWidth val="80"/>
+        <c:axId val="48650112"/>
+        <c:axId val="48672768"/>
+      </c:barChart>
+      <c:catAx>
+        <c:axId val="48650112"/>
+        <c:scaling>
+          <c:orientation val="minMax"/>
+        </c:scaling>
+        <c:delete val="0"/>
+        <c:axPos val="b"/>
+        <c:numFmt formatCode="General"/>
+        <c:majorTickMark val="none"/>
+        <c:minorTickMark val="none"/>
+        <c:spPr>
+          <a:ln xmlns:a="http://schemas.openxmlformats.org/drawingml/2006/main" w="9525">
+            <a:solidFill>
+              <a:srgbClr val="B8BCC4"/>
+            </a:solidFill>
+            <a:prstDash val="solid"/>
+          </a:ln>
+        </c:spPr>
+        <c:txPr>
+          <a:bodyPr xmlns:a="http://schemas.openxmlformats.org/drawingml/2006/main" anchorCtr="1"/>
+          <a:lstStyle xmlns:a="http://schemas.openxmlformats.org/drawingml/2006/main"/>
+          <a:p xmlns:a="http://schemas.openxmlformats.org/drawingml/2006/main">
+            <a:pPr>
+              <a:defRPr sz="825">
+                <a:solidFill>
+                  <a:srgbClr val="333333"/>
+                </a:solidFill>
+              </a:defRPr>
+            </a:pPr>
+          </a:p>
+        </c:txPr>
+        <c:crossAx val="48672768"/>
+      </c:catAx>
+      <c:valAx>
+        <c:axId val="48672768"/>
+        <c:scaling>
+          <c:orientation val="minMax"/>
+          <c:max val="30"/>
+          <c:min val="0"/>
+        </c:scaling>
+        <c:delete val="0"/>
+        <c:axPos val="l"/>
+        <c:majorGridlines>
+          <c:spPr>
+            <a:ln xmlns:a="http://schemas.openxmlformats.org/drawingml/2006/main" w="9525">
+              <a:solidFill>
+                <a:srgbClr val="EDEDED"/>
+              </a:solidFill>
+              <a:prstDash val="solid"/>
+            </a:ln>
+          </c:spPr>
+        </c:majorGridlines>
+        <c:numFmt formatCode="0"/>
+        <c:majorTickMark val="none"/>
+        <c:minorTickMark val="none"/>
+        <c:spPr>
+          <a:ln xmlns:a="http://schemas.openxmlformats.org/drawingml/2006/main" w="0">
+            <a:solidFill>
+              <a:srgbClr val="FFFFFF"/>
+            </a:solidFill>
+            <a:prstDash val="solid"/>
+          </a:ln>
+        </c:spPr>
+        <c:txPr>
+          <a:bodyPr xmlns:a="http://schemas.openxmlformats.org/drawingml/2006/main" anchorCtr="1"/>
+          <a:lstStyle xmlns:a="http://schemas.openxmlformats.org/drawingml/2006/main"/>
+          <a:p xmlns:a="http://schemas.openxmlformats.org/drawingml/2006/main">
+            <a:pPr>
+              <a:defRPr sz="825">
+                <a:solidFill>
+                  <a:srgbClr val="333333"/>
+                </a:solidFill>
+              </a:defRPr>
+            </a:pPr>
+          </a:p>
+        </c:txPr>
+        <c:crossAx val="48650112"/>
+        <c:crossBetween val="between"/>
+        <c:majorUnit val="5"/>
+      </c:valAx>
+      <c:spPr>
+        <a:noFill xmlns:a="http://schemas.openxmlformats.org/drawingml/2006/main"/>
+        <a:ln xmlns:a="http://schemas.openxmlformats.org/drawingml/2006/main" w="0">
+          <a:solidFill>
+            <a:srgbClr val="FFFFFF"/>
+          </a:solidFill>
+          <a:prstDash val="solid"/>
+        </a:ln>
+      </c:spPr>
+    </c:plotArea>
+    <c:legend>
+      <c:legendPos val="b"/>
+      <c:overlay val="0"/>
+      <c:txPr>
+        <a:bodyPr xmlns:a="http://schemas.openxmlformats.org/drawingml/2006/main" anchorCtr="1"/>
+        <a:lstStyle xmlns:a="http://schemas.openxmlformats.org/drawingml/2006/main"/>
+        <a:p xmlns:a="http://schemas.openxmlformats.org/drawingml/2006/main">
+          <a:pPr>
+            <a:defRPr sz="900">
+              <a:solidFill>
+                <a:srgbClr val="333333"/>
+              </a:solidFill>
+            </a:defRPr>
+          </a:pPr>
+        </a:p>
+      </c:txPr>
+    </c:legend>
+    <c:plotVisOnly val="1"/>
+  </c:chart>
+  <c:spPr>
+    <a:solidFill xmlns:a="http://schemas.openxmlformats.org/drawingml/2006/main">
+      <a:srgbClr val="FFFFFF"/>
+    </a:solidFill>
+    <a:ln xmlns:a="http://schemas.openxmlformats.org/drawingml/2006/main" w="0">
+      <a:solidFill>
+        <a:srgbClr val="FFFFFF"/>
+      </a:solidFill>
+      <a:prstDash val="solid"/>
+    </a:ln>
+  </c:spPr>
+</c:chartSpace>
+</file>
+
 <file path=ppt/slides/slide1.xml><?xml version="1.0" encoding="utf-8"?>
 <p:sld xmlns:p="http://schemas.openxmlformats.org/presentationml/2006/main">
   <p:cSld>
@@ -1817,6 +2483,7 @@
           <a:lstStyle xmlns:a="http://schemas.openxmlformats.org/drawingml/2006/main"/>
           <a:p xmlns:a="http://schemas.openxmlformats.org/drawingml/2006/main">
             <a:pPr>
+              <a:buNone/>
               <a:defRPr sz="3600" b="1">
                 <a:solidFill>
                   <a:srgbClr val="000000"/>
@@ -1873,6 +2540,7 @@
           <a:lstStyle xmlns:a="http://schemas.openxmlformats.org/drawingml/2006/main"/>
           <a:p xmlns:a="http://schemas.openxmlformats.org/drawingml/2006/main">
             <a:pPr>
+              <a:buNone/>
               <a:defRPr sz="1425" b="1">
                 <a:solidFill>
                   <a:srgbClr val="444444"/>
@@ -1898,7 +2566,7 @@
       </p:sp>
       <p:graphicFrame>
         <p:nvGraphicFramePr>
-          <p:cNvPr id="15" name="Chart"/>
+          <p:cNvPr id="17" name="Chart"/>
           <p:cNvGraphicFramePr/>
           <p:nvPr/>
         </p:nvGraphicFramePr>
@@ -1908,7 +2576,7 @@
         </p:xfrm>
         <a:graphic xmlns:a="http://schemas.openxmlformats.org/drawingml/2006/main">
           <a:graphicData uri="http://schemas.openxmlformats.org/drawingml/2006/chart">
-            <c:chart xmlns:r="http://schemas.openxmlformats.org/officeDocument/2006/relationships" xmlns:c="http://schemas.openxmlformats.org/drawingml/2006/chart" r:id="Rb6c107bf72e1456c"/>
+            <c:chart xmlns:r="http://schemas.openxmlformats.org/officeDocument/2006/relationships" xmlns:c="http://schemas.openxmlformats.org/drawingml/2006/chart" r:id="Re31ebe76e4d94b2e"/>
           </a:graphicData>
         </a:graphic>
       </p:graphicFrame>
@@ -1945,6 +2613,7 @@
           <a:lstStyle xmlns:a="http://schemas.openxmlformats.org/drawingml/2006/main"/>
           <a:p xmlns:a="http://schemas.openxmlformats.org/drawingml/2006/main">
             <a:pPr>
+              <a:buNone/>
               <a:defRPr sz="1650">
                 <a:solidFill>
                   <a:srgbClr val="000000"/>
@@ -2034,6 +2703,7 @@
           <a:lstStyle xmlns:a="http://schemas.openxmlformats.org/drawingml/2006/main"/>
           <a:p xmlns:a="http://schemas.openxmlformats.org/drawingml/2006/main">
             <a:pPr>
+              <a:buNone/>
               <a:defRPr sz="2850" b="1">
                 <a:solidFill>
                   <a:srgbClr val="1769E0"/>
@@ -2090,6 +2760,7 @@
           <a:lstStyle xmlns:a="http://schemas.openxmlformats.org/drawingml/2006/main"/>
           <a:p xmlns:a="http://schemas.openxmlformats.org/drawingml/2006/main">
             <a:pPr>
+              <a:buNone/>
               <a:defRPr sz="1650">
                 <a:solidFill>
                   <a:srgbClr val="000000"/>
@@ -2179,6 +2850,7 @@
           <a:lstStyle xmlns:a="http://schemas.openxmlformats.org/drawingml/2006/main"/>
           <a:p xmlns:a="http://schemas.openxmlformats.org/drawingml/2006/main">
             <a:pPr>
+              <a:buNone/>
               <a:defRPr sz="2850" b="1">
                 <a:solidFill>
                   <a:srgbClr val="1769E0"/>
@@ -2235,6 +2907,7 @@
           <a:lstStyle xmlns:a="http://schemas.openxmlformats.org/drawingml/2006/main"/>
           <a:p xmlns:a="http://schemas.openxmlformats.org/drawingml/2006/main">
             <a:pPr>
+              <a:buNone/>
               <a:defRPr sz="1650">
                 <a:solidFill>
                   <a:srgbClr val="000000"/>
@@ -2291,6 +2964,7 @@
           <a:lstStyle xmlns:a="http://schemas.openxmlformats.org/drawingml/2006/main"/>
           <a:p xmlns:a="http://schemas.openxmlformats.org/drawingml/2006/main">
             <a:pPr>
+              <a:buNone/>
               <a:defRPr sz="975">
                 <a:solidFill>
                   <a:srgbClr val="666666"/>
@@ -2347,6 +3021,7 @@
           <a:lstStyle xmlns:a="http://schemas.openxmlformats.org/drawingml/2006/main"/>
           <a:p xmlns:a="http://schemas.openxmlformats.org/drawingml/2006/main">
             <a:pPr algn="r">
+              <a:buNone/>
               <a:defRPr sz="975">
                 <a:solidFill>
                   <a:srgbClr val="444444"/>
@@ -2432,6 +3107,7 @@
           <a:lstStyle xmlns:a="http://schemas.openxmlformats.org/drawingml/2006/main"/>
           <a:p xmlns:a="http://schemas.openxmlformats.org/drawingml/2006/main">
             <a:pPr>
+              <a:buNone/>
               <a:defRPr sz="3600" b="1">
                 <a:solidFill>
                   <a:srgbClr val="000000"/>
@@ -2457,7 +3133,7 @@
       </p:sp>
       <p:graphicFrame>
         <p:nvGraphicFramePr>
-          <p:cNvPr id="15" name="Chart"/>
+          <p:cNvPr id="17" name="Chart"/>
           <p:cNvGraphicFramePr/>
           <p:nvPr/>
         </p:nvGraphicFramePr>
@@ -2467,7 +3143,7 @@
         </p:xfrm>
         <a:graphic xmlns:a="http://schemas.openxmlformats.org/drawingml/2006/main">
           <a:graphicData uri="http://schemas.openxmlformats.org/drawingml/2006/chart">
-            <c:chart xmlns:r="http://schemas.openxmlformats.org/officeDocument/2006/relationships" xmlns:c="http://schemas.openxmlformats.org/drawingml/2006/chart" r:id="R3cfbd0954ed14e0c"/>
+            <c:chart xmlns:r="http://schemas.openxmlformats.org/officeDocument/2006/relationships" xmlns:c="http://schemas.openxmlformats.org/drawingml/2006/chart" r:id="Reff25a675a3d4686"/>
           </a:graphicData>
         </a:graphic>
       </p:graphicFrame>
@@ -2537,6 +3213,7 @@
           <a:lstStyle xmlns:a="http://schemas.openxmlformats.org/drawingml/2006/main"/>
           <a:p xmlns:a="http://schemas.openxmlformats.org/drawingml/2006/main">
             <a:pPr>
+              <a:buNone/>
               <a:defRPr sz="2400" b="1">
                 <a:solidFill>
                   <a:srgbClr val="1769E0"/>
@@ -2593,6 +3270,7 @@
           <a:lstStyle xmlns:a="http://schemas.openxmlformats.org/drawingml/2006/main"/>
           <a:p xmlns:a="http://schemas.openxmlformats.org/drawingml/2006/main">
             <a:pPr>
+              <a:buNone/>
               <a:defRPr sz="1500">
                 <a:solidFill>
                   <a:srgbClr val="000000"/>
@@ -2682,6 +3360,7 @@
           <a:lstStyle xmlns:a="http://schemas.openxmlformats.org/drawingml/2006/main"/>
           <a:p xmlns:a="http://schemas.openxmlformats.org/drawingml/2006/main">
             <a:pPr>
+              <a:buNone/>
               <a:defRPr sz="2400" b="1">
                 <a:solidFill>
                   <a:srgbClr val="1769E0"/>
@@ -2738,6 +3417,7 @@
           <a:lstStyle xmlns:a="http://schemas.openxmlformats.org/drawingml/2006/main"/>
           <a:p xmlns:a="http://schemas.openxmlformats.org/drawingml/2006/main">
             <a:pPr>
+              <a:buNone/>
               <a:defRPr sz="1500">
                 <a:solidFill>
                   <a:srgbClr val="000000"/>
@@ -2827,6 +3507,7 @@
           <a:lstStyle xmlns:a="http://schemas.openxmlformats.org/drawingml/2006/main"/>
           <a:p xmlns:a="http://schemas.openxmlformats.org/drawingml/2006/main">
             <a:pPr>
+              <a:buNone/>
               <a:defRPr sz="2400" b="1">
                 <a:solidFill>
                   <a:srgbClr val="1769E0"/>
@@ -2883,6 +3564,7 @@
           <a:lstStyle xmlns:a="http://schemas.openxmlformats.org/drawingml/2006/main"/>
           <a:p xmlns:a="http://schemas.openxmlformats.org/drawingml/2006/main">
             <a:pPr>
+              <a:buNone/>
               <a:defRPr sz="1500">
                 <a:solidFill>
                   <a:srgbClr val="000000"/>
@@ -2939,6 +3621,7 @@
           <a:lstStyle xmlns:a="http://schemas.openxmlformats.org/drawingml/2006/main"/>
           <a:p xmlns:a="http://schemas.openxmlformats.org/drawingml/2006/main">
             <a:pPr>
+              <a:buNone/>
               <a:defRPr sz="975">
                 <a:solidFill>
                   <a:srgbClr val="666666"/>
@@ -2995,6 +3678,7 @@
           <a:lstStyle xmlns:a="http://schemas.openxmlformats.org/drawingml/2006/main"/>
           <a:p xmlns:a="http://schemas.openxmlformats.org/drawingml/2006/main">
             <a:pPr algn="r">
+              <a:buNone/>
               <a:defRPr sz="975">
                 <a:solidFill>
                   <a:srgbClr val="444444"/>
@@ -3014,6 +3698,1320 @@
                 <a:cs typeface="Helvetica Neue"/>
               </a:rPr>
               <a:t>2</a:t>
+            </a:r>
+          </a:p>
+        </p:txBody>
+      </p:sp>
+    </p:spTree>
+    <p:extLst>
+      <p:ext uri="{BB962C8B-B14F-4D97-AF65-F5344CB8AC3E}">
+        <p14:creationId xmlns:p14="http://schemas.microsoft.com/office/powerpoint/2010/main" val="1591286560"/>
+      </p:ext>
+    </p:extLst>
+  </p:cSld>
+</p:sld>
+</file>
+
+<file path=ppt/slides/slide3.xml><?xml version="1.0" encoding="utf-8"?>
+<p:sld xmlns:p="http://schemas.openxmlformats.org/presentationml/2006/main">
+  <p:cSld>
+    <p:bg>
+      <p:bgPr>
+        <a:solidFill xmlns:a="http://schemas.openxmlformats.org/drawingml/2006/main">
+          <a:srgbClr val="FFFFFF"/>
+        </a:solidFill>
+      </p:bgPr>
+    </p:bg>
+    <p:spTree>
+      <p:nvGrpSpPr>
+        <p:cNvPr id="1" name=""/>
+        <p:cNvGrpSpPr/>
+        <p:nvPr/>
+      </p:nvGrpSpPr>
+      <p:grpSpPr>
+        <a:xfrm xmlns:a="http://schemas.openxmlformats.org/drawingml/2006/main"/>
+      </p:grpSpPr>
+      <p:sp>
+        <p:nvSpPr>
+          <p:cNvPr id="14" name="slide2-title">
+            <a:extLst xmlns:a="http://schemas.openxmlformats.org/drawingml/2006/main">
+              <a:ext uri="{FF2B5EF4-FFF2-40B4-BE49-F238E27FC236}">
+                <a16:creationId xmlns:a16="http://schemas.microsoft.com/office/drawing/2014/main" id="{F7DFBAA9-EBA7-44D0-A23B-7E60B3715E23}"/>
+              </a:ext>
+            </a:extLst>
+          </p:cNvPr>
+          <p:cNvSpPr>
+            <a:spLocks xmlns:a="http://schemas.openxmlformats.org/drawingml/2006/main" noGrp="1"/>
+          </p:cNvSpPr>
+          <p:nvPr/>
+        </p:nvSpPr>
+        <p:spPr>
+          <a:xfrm xmlns:a="http://schemas.openxmlformats.org/drawingml/2006/main">
+            <a:off x="400050" y="323850"/>
+            <a:ext cx="11391900" cy="590550"/>
+          </a:xfrm>
+          <a:prstGeom xmlns:a="http://schemas.openxmlformats.org/drawingml/2006/main" prst="rect">
+            <a:avLst/>
+          </a:prstGeom>
+          <a:noFill xmlns:a="http://schemas.openxmlformats.org/drawingml/2006/main"/>
+          <a:ln xmlns:a="http://schemas.openxmlformats.org/drawingml/2006/main" w="0">
+            <a:noFill/>
+            <a:prstDash val="solid"/>
+          </a:ln>
+        </p:spPr>
+        <p:txBody>
+          <a:bodyPr xmlns:a="http://schemas.openxmlformats.org/drawingml/2006/main" anchor="t"/>
+          <a:lstStyle xmlns:a="http://schemas.openxmlformats.org/drawingml/2006/main"/>
+          <a:p xmlns:a="http://schemas.openxmlformats.org/drawingml/2006/main">
+            <a:pPr>
+              <a:buNone/>
+              <a:defRPr sz="3600" b="1">
+                <a:solidFill>
+                  <a:srgbClr val="000000"/>
+                </a:solidFill>
+                <a:latin typeface="Helvetica Neue"/>
+                <a:ea typeface="Helvetica Neue"/>
+                <a:cs typeface="Helvetica Neue"/>
+              </a:defRPr>
+            </a:pPr>
+            <a:r>
+              <a:rPr sz="3600" b="1">
+                <a:solidFill>
+                  <a:srgbClr val="000000"/>
+                </a:solidFill>
+                <a:latin typeface="Helvetica Neue"/>
+                <a:ea typeface="Helvetica Neue"/>
+                <a:cs typeface="Helvetica Neue"/>
+              </a:rPr>
+              <a:t>Методика учитывает возраст счёта</a:t>
+            </a:r>
+          </a:p>
+        </p:txBody>
+      </p:sp>
+      <p:graphicFrame>
+        <p:nvGraphicFramePr>
+          <p:cNvPr id="17" name="Chart"/>
+          <p:cNvGraphicFramePr/>
+          <p:nvPr/>
+        </p:nvGraphicFramePr>
+        <p:xfrm>
+          <a:off xmlns:a="http://schemas.openxmlformats.org/drawingml/2006/main" x="381000" y="1200150"/>
+          <a:ext xmlns:a="http://schemas.openxmlformats.org/drawingml/2006/main" cx="5524500" cy="5000625"/>
+        </p:xfrm>
+        <a:graphic xmlns:a="http://schemas.openxmlformats.org/drawingml/2006/main">
+          <a:graphicData uri="http://schemas.openxmlformats.org/drawingml/2006/chart">
+            <c:chart xmlns:r="http://schemas.openxmlformats.org/officeDocument/2006/relationships" xmlns:c="http://schemas.openxmlformats.org/drawingml/2006/chart" r:id="R8a62830263394edc"/>
+          </a:graphicData>
+        </a:graphic>
+      </p:graphicFrame>
+      <p:sp>
+        <p:nvSpPr>
+          <p:cNvPr id="3" name="slide2-panel-1">
+            <a:extLst xmlns:a="http://schemas.openxmlformats.org/drawingml/2006/main">
+              <a:ext uri="{FF2B5EF4-FFF2-40B4-BE49-F238E27FC236}">
+                <a16:creationId xmlns:a16="http://schemas.microsoft.com/office/drawing/2014/main" id="{71BE8BF3-4117-437F-A07F-9FDA57505565}"/>
+              </a:ext>
+            </a:extLst>
+          </p:cNvPr>
+          <p:cNvSpPr>
+            <a:spLocks xmlns:a="http://schemas.openxmlformats.org/drawingml/2006/main" noGrp="1"/>
+          </p:cNvSpPr>
+          <p:nvPr/>
+        </p:nvSpPr>
+        <p:spPr>
+          <a:xfrm xmlns:a="http://schemas.openxmlformats.org/drawingml/2006/main">
+            <a:off x="6267450" y="1200150"/>
+            <a:ext cx="5534025" cy="1428750"/>
+          </a:xfrm>
+          <a:prstGeom xmlns:a="http://schemas.openxmlformats.org/drawingml/2006/main" prst="rect">
+            <a:avLst/>
+          </a:prstGeom>
+          <a:solidFill xmlns:a="http://schemas.openxmlformats.org/drawingml/2006/main">
+            <a:srgbClr val="F2F2F2"/>
+          </a:solidFill>
+          <a:ln xmlns:a="http://schemas.openxmlformats.org/drawingml/2006/main" w="0">
+            <a:solidFill>
+              <a:srgbClr val="F2F2F2"/>
+            </a:solidFill>
+            <a:prstDash val="solid"/>
+          </a:ln>
+        </p:spPr>
+      </p:sp>
+      <p:sp>
+        <p:nvSpPr>
+          <p:cNvPr id="4" name="slide2-stat-1">
+            <a:extLst xmlns:a="http://schemas.openxmlformats.org/drawingml/2006/main">
+              <a:ext uri="{FF2B5EF4-FFF2-40B4-BE49-F238E27FC236}">
+                <a16:creationId xmlns:a16="http://schemas.microsoft.com/office/drawing/2014/main" id="{271BD13D-F2DD-4F56-97BF-40B57478B1F7}"/>
+              </a:ext>
+            </a:extLst>
+          </p:cNvPr>
+          <p:cNvSpPr>
+            <a:spLocks xmlns:a="http://schemas.openxmlformats.org/drawingml/2006/main" noGrp="1"/>
+          </p:cNvSpPr>
+          <p:nvPr/>
+        </p:nvSpPr>
+        <p:spPr>
+          <a:xfrm xmlns:a="http://schemas.openxmlformats.org/drawingml/2006/main">
+            <a:off x="6572250" y="1419225"/>
+            <a:ext cx="4905375" cy="457200"/>
+          </a:xfrm>
+          <a:prstGeom xmlns:a="http://schemas.openxmlformats.org/drawingml/2006/main" prst="rect">
+            <a:avLst/>
+          </a:prstGeom>
+          <a:noFill xmlns:a="http://schemas.openxmlformats.org/drawingml/2006/main"/>
+          <a:ln xmlns:a="http://schemas.openxmlformats.org/drawingml/2006/main" w="0">
+            <a:noFill/>
+            <a:prstDash val="solid"/>
+          </a:ln>
+        </p:spPr>
+        <p:txBody>
+          <a:bodyPr xmlns:a="http://schemas.openxmlformats.org/drawingml/2006/main" anchor="t"/>
+          <a:lstStyle xmlns:a="http://schemas.openxmlformats.org/drawingml/2006/main"/>
+          <a:p xmlns:a="http://schemas.openxmlformats.org/drawingml/2006/main">
+            <a:pPr>
+              <a:buNone/>
+              <a:defRPr sz="2400" b="1">
+                <a:solidFill>
+                  <a:srgbClr val="1769E0"/>
+                </a:solidFill>
+                <a:latin typeface="Helvetica Neue"/>
+                <a:ea typeface="Helvetica Neue"/>
+                <a:cs typeface="Helvetica Neue"/>
+              </a:defRPr>
+            </a:pPr>
+            <a:r>
+              <a:rPr sz="2400" b="1">
+                <a:solidFill>
+                  <a:srgbClr val="1769E0"/>
+                </a:solidFill>
+                <a:latin typeface="Helvetica Neue"/>
+                <a:ea typeface="Helvetica Neue"/>
+                <a:cs typeface="Helvetica Neue"/>
+              </a:rPr>
+              <a:t>Счёт</a:t>
+            </a:r>
+          </a:p>
+        </p:txBody>
+      </p:sp>
+      <p:sp>
+        <p:nvSpPr>
+          <p:cNvPr id="5" name="slide2-label-1">
+            <a:extLst xmlns:a="http://schemas.openxmlformats.org/drawingml/2006/main">
+              <a:ext uri="{FF2B5EF4-FFF2-40B4-BE49-F238E27FC236}">
+                <a16:creationId xmlns:a16="http://schemas.microsoft.com/office/drawing/2014/main" id="{B9221B50-1322-48A8-9598-C95CB1FFF80E}"/>
+              </a:ext>
+            </a:extLst>
+          </p:cNvPr>
+          <p:cNvSpPr>
+            <a:spLocks xmlns:a="http://schemas.openxmlformats.org/drawingml/2006/main" noGrp="1"/>
+          </p:cNvSpPr>
+          <p:nvPr/>
+        </p:nvSpPr>
+        <p:spPr>
+          <a:xfrm xmlns:a="http://schemas.openxmlformats.org/drawingml/2006/main">
+            <a:off x="6572250" y="1952625"/>
+            <a:ext cx="4905375" cy="523875"/>
+          </a:xfrm>
+          <a:prstGeom xmlns:a="http://schemas.openxmlformats.org/drawingml/2006/main" prst="rect">
+            <a:avLst/>
+          </a:prstGeom>
+          <a:noFill xmlns:a="http://schemas.openxmlformats.org/drawingml/2006/main"/>
+          <a:ln xmlns:a="http://schemas.openxmlformats.org/drawingml/2006/main" w="0">
+            <a:noFill/>
+            <a:prstDash val="solid"/>
+          </a:ln>
+        </p:spPr>
+        <p:txBody>
+          <a:bodyPr xmlns:a="http://schemas.openxmlformats.org/drawingml/2006/main" anchor="t"/>
+          <a:lstStyle xmlns:a="http://schemas.openxmlformats.org/drawingml/2006/main"/>
+          <a:p xmlns:a="http://schemas.openxmlformats.org/drawingml/2006/main">
+            <a:pPr>
+              <a:buNone/>
+              <a:defRPr sz="1500">
+                <a:solidFill>
+                  <a:srgbClr val="000000"/>
+                </a:solidFill>
+                <a:latin typeface="Helvetica Neue"/>
+                <a:ea typeface="Helvetica Neue"/>
+                <a:cs typeface="Helvetica Neue"/>
+              </a:defRPr>
+            </a:pPr>
+            <a:r>
+              <a:rPr sz="1500">
+                <a:solidFill>
+                  <a:srgbClr val="000000"/>
+                </a:solidFill>
+                <a:latin typeface="Helvetica Neue"/>
+                <a:ea typeface="Helvetica Neue"/>
+                <a:cs typeface="Helvetica Neue"/>
+              </a:rPr>
+              <a:t>единица анализа: CLIENT_ID + OPEN_DATE</a:t>
+            </a:r>
+          </a:p>
+        </p:txBody>
+      </p:sp>
+      <p:sp>
+        <p:nvSpPr>
+          <p:cNvPr id="6" name="slide2-panel-2">
+            <a:extLst xmlns:a="http://schemas.openxmlformats.org/drawingml/2006/main">
+              <a:ext uri="{FF2B5EF4-FFF2-40B4-BE49-F238E27FC236}">
+                <a16:creationId xmlns:a16="http://schemas.microsoft.com/office/drawing/2014/main" id="{2967ABD8-699E-4E8D-88EB-E248FD0C86A2}"/>
+              </a:ext>
+            </a:extLst>
+          </p:cNvPr>
+          <p:cNvSpPr>
+            <a:spLocks xmlns:a="http://schemas.openxmlformats.org/drawingml/2006/main" noGrp="1"/>
+          </p:cNvSpPr>
+          <p:nvPr/>
+        </p:nvSpPr>
+        <p:spPr>
+          <a:xfrm xmlns:a="http://schemas.openxmlformats.org/drawingml/2006/main">
+            <a:off x="6267450" y="2857500"/>
+            <a:ext cx="5534025" cy="1428750"/>
+          </a:xfrm>
+          <a:prstGeom xmlns:a="http://schemas.openxmlformats.org/drawingml/2006/main" prst="rect">
+            <a:avLst/>
+          </a:prstGeom>
+          <a:solidFill xmlns:a="http://schemas.openxmlformats.org/drawingml/2006/main">
+            <a:srgbClr val="F2F2F2"/>
+          </a:solidFill>
+          <a:ln xmlns:a="http://schemas.openxmlformats.org/drawingml/2006/main" w="0">
+            <a:solidFill>
+              <a:srgbClr val="F2F2F2"/>
+            </a:solidFill>
+            <a:prstDash val="solid"/>
+          </a:ln>
+        </p:spPr>
+      </p:sp>
+      <p:sp>
+        <p:nvSpPr>
+          <p:cNvPr id="7" name="slide2-stat-2">
+            <a:extLst xmlns:a="http://schemas.openxmlformats.org/drawingml/2006/main">
+              <a:ext uri="{FF2B5EF4-FFF2-40B4-BE49-F238E27FC236}">
+                <a16:creationId xmlns:a16="http://schemas.microsoft.com/office/drawing/2014/main" id="{49E7949B-6F82-4715-8C20-20792BAE5470}"/>
+              </a:ext>
+            </a:extLst>
+          </p:cNvPr>
+          <p:cNvSpPr>
+            <a:spLocks xmlns:a="http://schemas.openxmlformats.org/drawingml/2006/main" noGrp="1"/>
+          </p:cNvSpPr>
+          <p:nvPr/>
+        </p:nvSpPr>
+        <p:spPr>
+          <a:xfrm xmlns:a="http://schemas.openxmlformats.org/drawingml/2006/main">
+            <a:off x="6572250" y="3076575"/>
+            <a:ext cx="4905375" cy="457200"/>
+          </a:xfrm>
+          <a:prstGeom xmlns:a="http://schemas.openxmlformats.org/drawingml/2006/main" prst="rect">
+            <a:avLst/>
+          </a:prstGeom>
+          <a:noFill xmlns:a="http://schemas.openxmlformats.org/drawingml/2006/main"/>
+          <a:ln xmlns:a="http://schemas.openxmlformats.org/drawingml/2006/main" w="0">
+            <a:noFill/>
+            <a:prstDash val="solid"/>
+          </a:ln>
+        </p:spPr>
+        <p:txBody>
+          <a:bodyPr xmlns:a="http://schemas.openxmlformats.org/drawingml/2006/main" anchor="t"/>
+          <a:lstStyle xmlns:a="http://schemas.openxmlformats.org/drawingml/2006/main"/>
+          <a:p xmlns:a="http://schemas.openxmlformats.org/drawingml/2006/main">
+            <a:pPr>
+              <a:buNone/>
+              <a:defRPr sz="2400" b="1">
+                <a:solidFill>
+                  <a:srgbClr val="1769E0"/>
+                </a:solidFill>
+                <a:latin typeface="Helvetica Neue"/>
+                <a:ea typeface="Helvetica Neue"/>
+                <a:cs typeface="Helvetica Neue"/>
+              </a:defRPr>
+            </a:pPr>
+            <a:r>
+              <a:rPr sz="2400" b="1">
+                <a:solidFill>
+                  <a:srgbClr val="1769E0"/>
+                </a:solidFill>
+                <a:latin typeface="Helvetica Neue"/>
+                <a:ea typeface="Helvetica Neue"/>
+                <a:cs typeface="Helvetica Neue"/>
+              </a:rPr>
+              <a:t>Eligible t</a:t>
+            </a:r>
+          </a:p>
+        </p:txBody>
+      </p:sp>
+      <p:sp>
+        <p:nvSpPr>
+          <p:cNvPr id="8" name="slide2-label-2">
+            <a:extLst xmlns:a="http://schemas.openxmlformats.org/drawingml/2006/main">
+              <a:ext uri="{FF2B5EF4-FFF2-40B4-BE49-F238E27FC236}">
+                <a16:creationId xmlns:a16="http://schemas.microsoft.com/office/drawing/2014/main" id="{4D77AEC3-7EAA-4230-8638-E30BDE723A46}"/>
+              </a:ext>
+            </a:extLst>
+          </p:cNvPr>
+          <p:cNvSpPr>
+            <a:spLocks xmlns:a="http://schemas.openxmlformats.org/drawingml/2006/main" noGrp="1"/>
+          </p:cNvSpPr>
+          <p:nvPr/>
+        </p:nvSpPr>
+        <p:spPr>
+          <a:xfrm xmlns:a="http://schemas.openxmlformats.org/drawingml/2006/main">
+            <a:off x="6572250" y="3609975"/>
+            <a:ext cx="4905375" cy="523875"/>
+          </a:xfrm>
+          <a:prstGeom xmlns:a="http://schemas.openxmlformats.org/drawingml/2006/main" prst="rect">
+            <a:avLst/>
+          </a:prstGeom>
+          <a:noFill xmlns:a="http://schemas.openxmlformats.org/drawingml/2006/main"/>
+          <a:ln xmlns:a="http://schemas.openxmlformats.org/drawingml/2006/main" w="0">
+            <a:noFill/>
+            <a:prstDash val="solid"/>
+          </a:ln>
+        </p:spPr>
+        <p:txBody>
+          <a:bodyPr xmlns:a="http://schemas.openxmlformats.org/drawingml/2006/main" anchor="t"/>
+          <a:lstStyle xmlns:a="http://schemas.openxmlformats.org/drawingml/2006/main"/>
+          <a:p xmlns:a="http://schemas.openxmlformats.org/drawingml/2006/main">
+            <a:pPr>
+              <a:buNone/>
+              <a:defRPr sz="1500">
+                <a:solidFill>
+                  <a:srgbClr val="000000"/>
+                </a:solidFill>
+                <a:latin typeface="Helvetica Neue"/>
+                <a:ea typeface="Helvetica Neue"/>
+                <a:cs typeface="Helvetica Neue"/>
+              </a:defRPr>
+            </a:pPr>
+            <a:r>
+              <a:rPr sz="1500">
+                <a:solidFill>
+                  <a:srgbClr val="000000"/>
+                </a:solidFill>
+                <a:latin typeface="Helvetica Neue"/>
+                <a:ea typeface="Helvetica Neue"/>
+                <a:cs typeface="Helvetica Neue"/>
+              </a:rPr>
+              <a:t>в знаменателе только счета, успевшие дожить до месяца t</a:t>
+            </a:r>
+          </a:p>
+        </p:txBody>
+      </p:sp>
+      <p:sp>
+        <p:nvSpPr>
+          <p:cNvPr id="9" name="slide2-panel-3">
+            <a:extLst xmlns:a="http://schemas.openxmlformats.org/drawingml/2006/main">
+              <a:ext uri="{FF2B5EF4-FFF2-40B4-BE49-F238E27FC236}">
+                <a16:creationId xmlns:a16="http://schemas.microsoft.com/office/drawing/2014/main" id="{CAA7C704-AE6E-42D6-B948-0D90C2ECDCCC}"/>
+              </a:ext>
+            </a:extLst>
+          </p:cNvPr>
+          <p:cNvSpPr>
+            <a:spLocks xmlns:a="http://schemas.openxmlformats.org/drawingml/2006/main" noGrp="1"/>
+          </p:cNvSpPr>
+          <p:nvPr/>
+        </p:nvSpPr>
+        <p:spPr>
+          <a:xfrm xmlns:a="http://schemas.openxmlformats.org/drawingml/2006/main">
+            <a:off x="6267450" y="4514850"/>
+            <a:ext cx="5534025" cy="1428750"/>
+          </a:xfrm>
+          <a:prstGeom xmlns:a="http://schemas.openxmlformats.org/drawingml/2006/main" prst="rect">
+            <a:avLst/>
+          </a:prstGeom>
+          <a:solidFill xmlns:a="http://schemas.openxmlformats.org/drawingml/2006/main">
+            <a:srgbClr val="F2F2F2"/>
+          </a:solidFill>
+          <a:ln xmlns:a="http://schemas.openxmlformats.org/drawingml/2006/main" w="0">
+            <a:solidFill>
+              <a:srgbClr val="F2F2F2"/>
+            </a:solidFill>
+            <a:prstDash val="solid"/>
+          </a:ln>
+        </p:spPr>
+      </p:sp>
+      <p:sp>
+        <p:nvSpPr>
+          <p:cNvPr id="10" name="slide2-stat-3">
+            <a:extLst xmlns:a="http://schemas.openxmlformats.org/drawingml/2006/main">
+              <a:ext uri="{FF2B5EF4-FFF2-40B4-BE49-F238E27FC236}">
+                <a16:creationId xmlns:a16="http://schemas.microsoft.com/office/drawing/2014/main" id="{673C395B-47FB-4484-9655-08277FFE8D3B}"/>
+              </a:ext>
+            </a:extLst>
+          </p:cNvPr>
+          <p:cNvSpPr>
+            <a:spLocks xmlns:a="http://schemas.openxmlformats.org/drawingml/2006/main" noGrp="1"/>
+          </p:cNvSpPr>
+          <p:nvPr/>
+        </p:nvSpPr>
+        <p:spPr>
+          <a:xfrm xmlns:a="http://schemas.openxmlformats.org/drawingml/2006/main">
+            <a:off x="6572250" y="4733925"/>
+            <a:ext cx="4905375" cy="457200"/>
+          </a:xfrm>
+          <a:prstGeom xmlns:a="http://schemas.openxmlformats.org/drawingml/2006/main" prst="rect">
+            <a:avLst/>
+          </a:prstGeom>
+          <a:noFill xmlns:a="http://schemas.openxmlformats.org/drawingml/2006/main"/>
+          <a:ln xmlns:a="http://schemas.openxmlformats.org/drawingml/2006/main" w="0">
+            <a:noFill/>
+            <a:prstDash val="solid"/>
+          </a:ln>
+        </p:spPr>
+        <p:txBody>
+          <a:bodyPr xmlns:a="http://schemas.openxmlformats.org/drawingml/2006/main" anchor="t"/>
+          <a:lstStyle xmlns:a="http://schemas.openxmlformats.org/drawingml/2006/main"/>
+          <a:p xmlns:a="http://schemas.openxmlformats.org/drawingml/2006/main">
+            <a:pPr>
+              <a:buNone/>
+              <a:defRPr sz="2400" b="1">
+                <a:solidFill>
+                  <a:srgbClr val="1769E0"/>
+                </a:solidFill>
+                <a:latin typeface="Helvetica Neue"/>
+                <a:ea typeface="Helvetica Neue"/>
+                <a:cs typeface="Helvetica Neue"/>
+              </a:defRPr>
+            </a:pPr>
+            <a:r>
+              <a:rPr sz="2400" b="1">
+                <a:solidFill>
+                  <a:srgbClr val="1769E0"/>
+                </a:solidFill>
+                <a:latin typeface="Helvetica Neue"/>
+                <a:ea typeface="Helvetica Neue"/>
+                <a:cs typeface="Helvetica Neue"/>
+              </a:rPr>
+              <a:t>LTV</a:t>
+            </a:r>
+          </a:p>
+        </p:txBody>
+      </p:sp>
+      <p:sp>
+        <p:nvSpPr>
+          <p:cNvPr id="11" name="slide2-label-3">
+            <a:extLst xmlns:a="http://schemas.openxmlformats.org/drawingml/2006/main">
+              <a:ext uri="{FF2B5EF4-FFF2-40B4-BE49-F238E27FC236}">
+                <a16:creationId xmlns:a16="http://schemas.microsoft.com/office/drawing/2014/main" id="{7D5A923D-CF74-437E-890D-28540BE621DC}"/>
+              </a:ext>
+            </a:extLst>
+          </p:cNvPr>
+          <p:cNvSpPr>
+            <a:spLocks xmlns:a="http://schemas.openxmlformats.org/drawingml/2006/main" noGrp="1"/>
+          </p:cNvSpPr>
+          <p:nvPr/>
+        </p:nvSpPr>
+        <p:spPr>
+          <a:xfrm xmlns:a="http://schemas.openxmlformats.org/drawingml/2006/main">
+            <a:off x="6572250" y="5267325"/>
+            <a:ext cx="4905375" cy="523875"/>
+          </a:xfrm>
+          <a:prstGeom xmlns:a="http://schemas.openxmlformats.org/drawingml/2006/main" prst="rect">
+            <a:avLst/>
+          </a:prstGeom>
+          <a:noFill xmlns:a="http://schemas.openxmlformats.org/drawingml/2006/main"/>
+          <a:ln xmlns:a="http://schemas.openxmlformats.org/drawingml/2006/main" w="0">
+            <a:noFill/>
+            <a:prstDash val="solid"/>
+          </a:ln>
+        </p:spPr>
+        <p:txBody>
+          <a:bodyPr xmlns:a="http://schemas.openxmlformats.org/drawingml/2006/main" anchor="t"/>
+          <a:lstStyle xmlns:a="http://schemas.openxmlformats.org/drawingml/2006/main"/>
+          <a:p xmlns:a="http://schemas.openxmlformats.org/drawingml/2006/main">
+            <a:pPr>
+              <a:buNone/>
+              <a:defRPr sz="1500">
+                <a:solidFill>
+                  <a:srgbClr val="000000"/>
+                </a:solidFill>
+                <a:latin typeface="Helvetica Neue"/>
+                <a:ea typeface="Helvetica Neue"/>
+                <a:cs typeface="Helvetica Neue"/>
+              </a:defRPr>
+            </a:pPr>
+            <a:r>
+              <a:rPr sz="1500">
+                <a:solidFill>
+                  <a:srgbClr val="000000"/>
+                </a:solidFill>
+                <a:latin typeface="Helvetica Neue"/>
+                <a:ea typeface="Helvetica Neue"/>
+                <a:cs typeface="Helvetica Neue"/>
+              </a:rPr>
+              <a:t>комиссии + доход на остаток − сервис − CAC</a:t>
+            </a:r>
+          </a:p>
+        </p:txBody>
+      </p:sp>
+      <p:sp>
+        <p:nvSpPr>
+          <p:cNvPr id="12" name="source-2">
+            <a:extLst xmlns:a="http://schemas.openxmlformats.org/drawingml/2006/main">
+              <a:ext uri="{FF2B5EF4-FFF2-40B4-BE49-F238E27FC236}">
+                <a16:creationId xmlns:a16="http://schemas.microsoft.com/office/drawing/2014/main" id="{53E3A59F-FBEC-410F-A0AC-E643AAAE0B53}"/>
+              </a:ext>
+            </a:extLst>
+          </p:cNvPr>
+          <p:cNvSpPr>
+            <a:spLocks xmlns:a="http://schemas.openxmlformats.org/drawingml/2006/main" noGrp="1"/>
+          </p:cNvSpPr>
+          <p:nvPr/>
+        </p:nvSpPr>
+        <p:spPr>
+          <a:xfrm xmlns:a="http://schemas.openxmlformats.org/drawingml/2006/main">
+            <a:off x="400050" y="6429375"/>
+            <a:ext cx="9620250" cy="209550"/>
+          </a:xfrm>
+          <a:prstGeom xmlns:a="http://schemas.openxmlformats.org/drawingml/2006/main" prst="rect">
+            <a:avLst/>
+          </a:prstGeom>
+          <a:noFill xmlns:a="http://schemas.openxmlformats.org/drawingml/2006/main"/>
+          <a:ln xmlns:a="http://schemas.openxmlformats.org/drawingml/2006/main" w="0">
+            <a:noFill/>
+            <a:prstDash val="solid"/>
+          </a:ln>
+        </p:spPr>
+        <p:txBody>
+          <a:bodyPr xmlns:a="http://schemas.openxmlformats.org/drawingml/2006/main" anchor="t"/>
+          <a:lstStyle xmlns:a="http://schemas.openxmlformats.org/drawingml/2006/main"/>
+          <a:p xmlns:a="http://schemas.openxmlformats.org/drawingml/2006/main">
+            <a:pPr>
+              <a:buNone/>
+              <a:defRPr sz="975">
+                <a:solidFill>
+                  <a:srgbClr val="666666"/>
+                </a:solidFill>
+                <a:latin typeface="Helvetica Neue"/>
+                <a:ea typeface="Helvetica Neue"/>
+                <a:cs typeface="Helvetica Neue"/>
+              </a:defRPr>
+            </a:pPr>
+            <a:r>
+              <a:rPr sz="975">
+                <a:solidFill>
+                  <a:srgbClr val="666666"/>
+                </a:solidFill>
+                <a:latin typeface="Helvetica Neue"/>
+                <a:ea typeface="Helvetica Neue"/>
+                <a:cs typeface="Helvetica Neue"/>
+              </a:rPr>
+              <a:t>Источник: методология и формулы из README</a:t>
+            </a:r>
+          </a:p>
+        </p:txBody>
+      </p:sp>
+      <p:sp>
+        <p:nvSpPr>
+          <p:cNvPr id="13" name="page-2">
+            <a:extLst xmlns:a="http://schemas.openxmlformats.org/drawingml/2006/main">
+              <a:ext uri="{FF2B5EF4-FFF2-40B4-BE49-F238E27FC236}">
+                <a16:creationId xmlns:a16="http://schemas.microsoft.com/office/drawing/2014/main" id="{8FE0F372-C976-48A4-AA0C-B065922FD4B4}"/>
+              </a:ext>
+            </a:extLst>
+          </p:cNvPr>
+          <p:cNvSpPr>
+            <a:spLocks xmlns:a="http://schemas.openxmlformats.org/drawingml/2006/main" noGrp="1"/>
+          </p:cNvSpPr>
+          <p:nvPr/>
+        </p:nvSpPr>
+        <p:spPr>
+          <a:xfrm xmlns:a="http://schemas.openxmlformats.org/drawingml/2006/main">
+            <a:off x="11277600" y="6381750"/>
+            <a:ext cx="523875" cy="209550"/>
+          </a:xfrm>
+          <a:prstGeom xmlns:a="http://schemas.openxmlformats.org/drawingml/2006/main" prst="rect">
+            <a:avLst/>
+          </a:prstGeom>
+          <a:noFill xmlns:a="http://schemas.openxmlformats.org/drawingml/2006/main"/>
+          <a:ln xmlns:a="http://schemas.openxmlformats.org/drawingml/2006/main" w="0">
+            <a:noFill/>
+            <a:prstDash val="solid"/>
+          </a:ln>
+        </p:spPr>
+        <p:txBody>
+          <a:bodyPr xmlns:a="http://schemas.openxmlformats.org/drawingml/2006/main" anchor="t"/>
+          <a:lstStyle xmlns:a="http://schemas.openxmlformats.org/drawingml/2006/main"/>
+          <a:p xmlns:a="http://schemas.openxmlformats.org/drawingml/2006/main">
+            <a:pPr algn="r">
+              <a:buNone/>
+              <a:defRPr sz="975">
+                <a:solidFill>
+                  <a:srgbClr val="444444"/>
+                </a:solidFill>
+                <a:latin typeface="Helvetica Neue"/>
+                <a:ea typeface="Helvetica Neue"/>
+                <a:cs typeface="Helvetica Neue"/>
+              </a:defRPr>
+            </a:pPr>
+            <a:r>
+              <a:rPr sz="975">
+                <a:solidFill>
+                  <a:srgbClr val="444444"/>
+                </a:solidFill>
+                <a:latin typeface="Helvetica Neue"/>
+                <a:ea typeface="Helvetica Neue"/>
+                <a:cs typeface="Helvetica Neue"/>
+              </a:rPr>
+              <a:t>3</a:t>
+            </a:r>
+          </a:p>
+        </p:txBody>
+      </p:sp>
+    </p:spTree>
+    <p:extLst>
+      <p:ext uri="{BB962C8B-B14F-4D97-AF65-F5344CB8AC3E}">
+        <p14:creationId xmlns:p14="http://schemas.microsoft.com/office/powerpoint/2010/main" val="1591286560"/>
+      </p:ext>
+    </p:extLst>
+  </p:cSld>
+</p:sld>
+</file>
+
+<file path=ppt/slides/slide4.xml><?xml version="1.0" encoding="utf-8"?>
+<p:sld xmlns:p="http://schemas.openxmlformats.org/presentationml/2006/main">
+  <p:cSld>
+    <p:bg>
+      <p:bgPr>
+        <a:solidFill xmlns:a="http://schemas.openxmlformats.org/drawingml/2006/main">
+          <a:srgbClr val="FFFFFF"/>
+        </a:solidFill>
+      </p:bgPr>
+    </p:bg>
+    <p:spTree>
+      <p:nvGrpSpPr>
+        <p:cNvPr id="1" name=""/>
+        <p:cNvGrpSpPr/>
+        <p:nvPr/>
+      </p:nvGrpSpPr>
+      <p:grpSpPr>
+        <a:xfrm xmlns:a="http://schemas.openxmlformats.org/drawingml/2006/main"/>
+      </p:grpSpPr>
+      <p:sp>
+        <p:nvSpPr>
+          <p:cNvPr id="14" name="slide2-title">
+            <a:extLst xmlns:a="http://schemas.openxmlformats.org/drawingml/2006/main">
+              <a:ext uri="{FF2B5EF4-FFF2-40B4-BE49-F238E27FC236}">
+                <a16:creationId xmlns:a16="http://schemas.microsoft.com/office/drawing/2014/main" id="{F7DFBAA9-EBA7-44D0-A23B-7E60B3715E23}"/>
+              </a:ext>
+            </a:extLst>
+          </p:cNvPr>
+          <p:cNvSpPr>
+            <a:spLocks xmlns:a="http://schemas.openxmlformats.org/drawingml/2006/main" noGrp="1"/>
+          </p:cNvSpPr>
+          <p:nvPr/>
+        </p:nvSpPr>
+        <p:spPr>
+          <a:xfrm xmlns:a="http://schemas.openxmlformats.org/drawingml/2006/main">
+            <a:off x="400050" y="323850"/>
+            <a:ext cx="11391900" cy="590550"/>
+          </a:xfrm>
+          <a:prstGeom xmlns:a="http://schemas.openxmlformats.org/drawingml/2006/main" prst="rect">
+            <a:avLst/>
+          </a:prstGeom>
+          <a:noFill xmlns:a="http://schemas.openxmlformats.org/drawingml/2006/main"/>
+          <a:ln xmlns:a="http://schemas.openxmlformats.org/drawingml/2006/main" w="0">
+            <a:noFill/>
+            <a:prstDash val="solid"/>
+          </a:ln>
+        </p:spPr>
+        <p:txBody>
+          <a:bodyPr xmlns:a="http://schemas.openxmlformats.org/drawingml/2006/main" anchor="t"/>
+          <a:lstStyle xmlns:a="http://schemas.openxmlformats.org/drawingml/2006/main"/>
+          <a:p xmlns:a="http://schemas.openxmlformats.org/drawingml/2006/main">
+            <a:pPr>
+              <a:buNone/>
+              <a:defRPr sz="3600" b="1">
+                <a:solidFill>
+                  <a:srgbClr val="000000"/>
+                </a:solidFill>
+                <a:latin typeface="Helvetica Neue"/>
+                <a:ea typeface="Helvetica Neue"/>
+                <a:cs typeface="Helvetica Neue"/>
+              </a:defRPr>
+            </a:pPr>
+            <a:r>
+              <a:rPr sz="3600" b="1">
+                <a:solidFill>
+                  <a:srgbClr val="000000"/>
+                </a:solidFill>
+                <a:latin typeface="Helvetica Neue"/>
+                <a:ea typeface="Helvetica Neue"/>
+                <a:cs typeface="Helvetica Neue"/>
+              </a:rPr>
+              <a:t>Ограничения и проверяемость</a:t>
+            </a:r>
+          </a:p>
+        </p:txBody>
+      </p:sp>
+      <p:graphicFrame>
+        <p:nvGraphicFramePr>
+          <p:cNvPr id="17" name="Chart"/>
+          <p:cNvGraphicFramePr/>
+          <p:nvPr/>
+        </p:nvGraphicFramePr>
+        <p:xfrm>
+          <a:off xmlns:a="http://schemas.openxmlformats.org/drawingml/2006/main" x="381000" y="1200150"/>
+          <a:ext xmlns:a="http://schemas.openxmlformats.org/drawingml/2006/main" cx="5524500" cy="5000625"/>
+        </p:xfrm>
+        <a:graphic xmlns:a="http://schemas.openxmlformats.org/drawingml/2006/main">
+          <a:graphicData uri="http://schemas.openxmlformats.org/drawingml/2006/chart">
+            <c:chart xmlns:r="http://schemas.openxmlformats.org/officeDocument/2006/relationships" xmlns:c="http://schemas.openxmlformats.org/drawingml/2006/chart" r:id="Rf911a6cecf614712"/>
+          </a:graphicData>
+        </a:graphic>
+      </p:graphicFrame>
+      <p:sp>
+        <p:nvSpPr>
+          <p:cNvPr id="3" name="slide2-panel-1">
+            <a:extLst xmlns:a="http://schemas.openxmlformats.org/drawingml/2006/main">
+              <a:ext uri="{FF2B5EF4-FFF2-40B4-BE49-F238E27FC236}">
+                <a16:creationId xmlns:a16="http://schemas.microsoft.com/office/drawing/2014/main" id="{71BE8BF3-4117-437F-A07F-9FDA57505565}"/>
+              </a:ext>
+            </a:extLst>
+          </p:cNvPr>
+          <p:cNvSpPr>
+            <a:spLocks xmlns:a="http://schemas.openxmlformats.org/drawingml/2006/main" noGrp="1"/>
+          </p:cNvSpPr>
+          <p:nvPr/>
+        </p:nvSpPr>
+        <p:spPr>
+          <a:xfrm xmlns:a="http://schemas.openxmlformats.org/drawingml/2006/main">
+            <a:off x="6267450" y="1200150"/>
+            <a:ext cx="5534025" cy="1428750"/>
+          </a:xfrm>
+          <a:prstGeom xmlns:a="http://schemas.openxmlformats.org/drawingml/2006/main" prst="rect">
+            <a:avLst/>
+          </a:prstGeom>
+          <a:solidFill xmlns:a="http://schemas.openxmlformats.org/drawingml/2006/main">
+            <a:srgbClr val="F2F2F2"/>
+          </a:solidFill>
+          <a:ln xmlns:a="http://schemas.openxmlformats.org/drawingml/2006/main" w="0">
+            <a:solidFill>
+              <a:srgbClr val="F2F2F2"/>
+            </a:solidFill>
+            <a:prstDash val="solid"/>
+          </a:ln>
+        </p:spPr>
+      </p:sp>
+      <p:sp>
+        <p:nvSpPr>
+          <p:cNvPr id="4" name="slide2-stat-1">
+            <a:extLst xmlns:a="http://schemas.openxmlformats.org/drawingml/2006/main">
+              <a:ext uri="{FF2B5EF4-FFF2-40B4-BE49-F238E27FC236}">
+                <a16:creationId xmlns:a16="http://schemas.microsoft.com/office/drawing/2014/main" id="{271BD13D-F2DD-4F56-97BF-40B57478B1F7}"/>
+              </a:ext>
+            </a:extLst>
+          </p:cNvPr>
+          <p:cNvSpPr>
+            <a:spLocks xmlns:a="http://schemas.openxmlformats.org/drawingml/2006/main" noGrp="1"/>
+          </p:cNvSpPr>
+          <p:nvPr/>
+        </p:nvSpPr>
+        <p:spPr>
+          <a:xfrm xmlns:a="http://schemas.openxmlformats.org/drawingml/2006/main">
+            <a:off x="6572250" y="1419225"/>
+            <a:ext cx="4905375" cy="457200"/>
+          </a:xfrm>
+          <a:prstGeom xmlns:a="http://schemas.openxmlformats.org/drawingml/2006/main" prst="rect">
+            <a:avLst/>
+          </a:prstGeom>
+          <a:noFill xmlns:a="http://schemas.openxmlformats.org/drawingml/2006/main"/>
+          <a:ln xmlns:a="http://schemas.openxmlformats.org/drawingml/2006/main" w="0">
+            <a:noFill/>
+            <a:prstDash val="solid"/>
+          </a:ln>
+        </p:spPr>
+        <p:txBody>
+          <a:bodyPr xmlns:a="http://schemas.openxmlformats.org/drawingml/2006/main" anchor="t"/>
+          <a:lstStyle xmlns:a="http://schemas.openxmlformats.org/drawingml/2006/main"/>
+          <a:p xmlns:a="http://schemas.openxmlformats.org/drawingml/2006/main">
+            <a:pPr>
+              <a:buNone/>
+              <a:defRPr sz="2400" b="1">
+                <a:solidFill>
+                  <a:srgbClr val="1769E0"/>
+                </a:solidFill>
+                <a:latin typeface="Helvetica Neue"/>
+                <a:ea typeface="Helvetica Neue"/>
+                <a:cs typeface="Helvetica Neue"/>
+              </a:defRPr>
+            </a:pPr>
+            <a:r>
+              <a:rPr sz="2400" b="1">
+                <a:solidFill>
+                  <a:srgbClr val="1769E0"/>
+                </a:solidFill>
+                <a:latin typeface="Helvetica Neue"/>
+                <a:ea typeface="Helvetica Neue"/>
+                <a:cs typeface="Helvetica Neue"/>
+              </a:rPr>
+              <a:t>29 мес.</a:t>
+            </a:r>
+          </a:p>
+        </p:txBody>
+      </p:sp>
+      <p:sp>
+        <p:nvSpPr>
+          <p:cNvPr id="5" name="slide2-label-1">
+            <a:extLst xmlns:a="http://schemas.openxmlformats.org/drawingml/2006/main">
+              <a:ext uri="{FF2B5EF4-FFF2-40B4-BE49-F238E27FC236}">
+                <a16:creationId xmlns:a16="http://schemas.microsoft.com/office/drawing/2014/main" id="{B9221B50-1322-48A8-9598-C95CB1FFF80E}"/>
+              </a:ext>
+            </a:extLst>
+          </p:cNvPr>
+          <p:cNvSpPr>
+            <a:spLocks xmlns:a="http://schemas.openxmlformats.org/drawingml/2006/main" noGrp="1"/>
+          </p:cNvSpPr>
+          <p:nvPr/>
+        </p:nvSpPr>
+        <p:spPr>
+          <a:xfrm xmlns:a="http://schemas.openxmlformats.org/drawingml/2006/main">
+            <a:off x="6572250" y="1952625"/>
+            <a:ext cx="4905375" cy="523875"/>
+          </a:xfrm>
+          <a:prstGeom xmlns:a="http://schemas.openxmlformats.org/drawingml/2006/main" prst="rect">
+            <a:avLst/>
+          </a:prstGeom>
+          <a:noFill xmlns:a="http://schemas.openxmlformats.org/drawingml/2006/main"/>
+          <a:ln xmlns:a="http://schemas.openxmlformats.org/drawingml/2006/main" w="0">
+            <a:noFill/>
+            <a:prstDash val="solid"/>
+          </a:ln>
+        </p:spPr>
+        <p:txBody>
+          <a:bodyPr xmlns:a="http://schemas.openxmlformats.org/drawingml/2006/main" anchor="t"/>
+          <a:lstStyle xmlns:a="http://schemas.openxmlformats.org/drawingml/2006/main"/>
+          <a:p xmlns:a="http://schemas.openxmlformats.org/drawingml/2006/main">
+            <a:pPr>
+              <a:buNone/>
+              <a:defRPr sz="1500">
+                <a:solidFill>
+                  <a:srgbClr val="000000"/>
+                </a:solidFill>
+                <a:latin typeface="Helvetica Neue"/>
+                <a:ea typeface="Helvetica Neue"/>
+                <a:cs typeface="Helvetica Neue"/>
+              </a:defRPr>
+            </a:pPr>
+            <a:r>
+              <a:rPr sz="1500">
+                <a:solidFill>
+                  <a:srgbClr val="000000"/>
+                </a:solidFill>
+                <a:latin typeface="Helvetica Neue"/>
+                <a:ea typeface="Helvetica Neue"/>
+                <a:cs typeface="Helvetica Neue"/>
+              </a:rPr>
+              <a:t>LTV усечён наблюдаемым горизонтом</a:t>
+            </a:r>
+          </a:p>
+        </p:txBody>
+      </p:sp>
+      <p:sp>
+        <p:nvSpPr>
+          <p:cNvPr id="6" name="slide2-panel-2">
+            <a:extLst xmlns:a="http://schemas.openxmlformats.org/drawingml/2006/main">
+              <a:ext uri="{FF2B5EF4-FFF2-40B4-BE49-F238E27FC236}">
+                <a16:creationId xmlns:a16="http://schemas.microsoft.com/office/drawing/2014/main" id="{2967ABD8-699E-4E8D-88EB-E248FD0C86A2}"/>
+              </a:ext>
+            </a:extLst>
+          </p:cNvPr>
+          <p:cNvSpPr>
+            <a:spLocks xmlns:a="http://schemas.openxmlformats.org/drawingml/2006/main" noGrp="1"/>
+          </p:cNvSpPr>
+          <p:nvPr/>
+        </p:nvSpPr>
+        <p:spPr>
+          <a:xfrm xmlns:a="http://schemas.openxmlformats.org/drawingml/2006/main">
+            <a:off x="6267450" y="2857500"/>
+            <a:ext cx="5534025" cy="1428750"/>
+          </a:xfrm>
+          <a:prstGeom xmlns:a="http://schemas.openxmlformats.org/drawingml/2006/main" prst="rect">
+            <a:avLst/>
+          </a:prstGeom>
+          <a:solidFill xmlns:a="http://schemas.openxmlformats.org/drawingml/2006/main">
+            <a:srgbClr val="F2F2F2"/>
+          </a:solidFill>
+          <a:ln xmlns:a="http://schemas.openxmlformats.org/drawingml/2006/main" w="0">
+            <a:solidFill>
+              <a:srgbClr val="F2F2F2"/>
+            </a:solidFill>
+            <a:prstDash val="solid"/>
+          </a:ln>
+        </p:spPr>
+      </p:sp>
+      <p:sp>
+        <p:nvSpPr>
+          <p:cNvPr id="7" name="slide2-stat-2">
+            <a:extLst xmlns:a="http://schemas.openxmlformats.org/drawingml/2006/main">
+              <a:ext uri="{FF2B5EF4-FFF2-40B4-BE49-F238E27FC236}">
+                <a16:creationId xmlns:a16="http://schemas.microsoft.com/office/drawing/2014/main" id="{49E7949B-6F82-4715-8C20-20792BAE5470}"/>
+              </a:ext>
+            </a:extLst>
+          </p:cNvPr>
+          <p:cNvSpPr>
+            <a:spLocks xmlns:a="http://schemas.openxmlformats.org/drawingml/2006/main" noGrp="1"/>
+          </p:cNvSpPr>
+          <p:nvPr/>
+        </p:nvSpPr>
+        <p:spPr>
+          <a:xfrm xmlns:a="http://schemas.openxmlformats.org/drawingml/2006/main">
+            <a:off x="6572250" y="3076575"/>
+            <a:ext cx="4905375" cy="457200"/>
+          </a:xfrm>
+          <a:prstGeom xmlns:a="http://schemas.openxmlformats.org/drawingml/2006/main" prst="rect">
+            <a:avLst/>
+          </a:prstGeom>
+          <a:noFill xmlns:a="http://schemas.openxmlformats.org/drawingml/2006/main"/>
+          <a:ln xmlns:a="http://schemas.openxmlformats.org/drawingml/2006/main" w="0">
+            <a:noFill/>
+            <a:prstDash val="solid"/>
+          </a:ln>
+        </p:spPr>
+        <p:txBody>
+          <a:bodyPr xmlns:a="http://schemas.openxmlformats.org/drawingml/2006/main" anchor="t"/>
+          <a:lstStyle xmlns:a="http://schemas.openxmlformats.org/drawingml/2006/main"/>
+          <a:p xmlns:a="http://schemas.openxmlformats.org/drawingml/2006/main">
+            <a:pPr>
+              <a:buNone/>
+              <a:defRPr sz="2400" b="1">
+                <a:solidFill>
+                  <a:srgbClr val="1769E0"/>
+                </a:solidFill>
+                <a:latin typeface="Helvetica Neue"/>
+                <a:ea typeface="Helvetica Neue"/>
+                <a:cs typeface="Helvetica Neue"/>
+              </a:defRPr>
+            </a:pPr>
+            <a:r>
+              <a:rPr sz="2400" b="1">
+                <a:solidFill>
+                  <a:srgbClr val="1769E0"/>
+                </a:solidFill>
+                <a:latin typeface="Helvetica Neue"/>
+                <a:ea typeface="Helvetica Neue"/>
+                <a:cs typeface="Helvetica Neue"/>
+              </a:rPr>
+              <a:t>100 тыс.</a:t>
+            </a:r>
+          </a:p>
+        </p:txBody>
+      </p:sp>
+      <p:sp>
+        <p:nvSpPr>
+          <p:cNvPr id="8" name="slide2-label-2">
+            <a:extLst xmlns:a="http://schemas.openxmlformats.org/drawingml/2006/main">
+              <a:ext uri="{FF2B5EF4-FFF2-40B4-BE49-F238E27FC236}">
+                <a16:creationId xmlns:a16="http://schemas.microsoft.com/office/drawing/2014/main" id="{4D77AEC3-7EAA-4230-8638-E30BDE723A46}"/>
+              </a:ext>
+            </a:extLst>
+          </p:cNvPr>
+          <p:cNvSpPr>
+            <a:spLocks xmlns:a="http://schemas.openxmlformats.org/drawingml/2006/main" noGrp="1"/>
+          </p:cNvSpPr>
+          <p:nvPr/>
+        </p:nvSpPr>
+        <p:spPr>
+          <a:xfrm xmlns:a="http://schemas.openxmlformats.org/drawingml/2006/main">
+            <a:off x="6572250" y="3609975"/>
+            <a:ext cx="4905375" cy="523875"/>
+          </a:xfrm>
+          <a:prstGeom xmlns:a="http://schemas.openxmlformats.org/drawingml/2006/main" prst="rect">
+            <a:avLst/>
+          </a:prstGeom>
+          <a:noFill xmlns:a="http://schemas.openxmlformats.org/drawingml/2006/main"/>
+          <a:ln xmlns:a="http://schemas.openxmlformats.org/drawingml/2006/main" w="0">
+            <a:noFill/>
+            <a:prstDash val="solid"/>
+          </a:ln>
+        </p:spPr>
+        <p:txBody>
+          <a:bodyPr xmlns:a="http://schemas.openxmlformats.org/drawingml/2006/main" anchor="t"/>
+          <a:lstStyle xmlns:a="http://schemas.openxmlformats.org/drawingml/2006/main"/>
+          <a:p xmlns:a="http://schemas.openxmlformats.org/drawingml/2006/main">
+            <a:pPr>
+              <a:buNone/>
+              <a:defRPr sz="1500">
+                <a:solidFill>
+                  <a:srgbClr val="000000"/>
+                </a:solidFill>
+                <a:latin typeface="Helvetica Neue"/>
+                <a:ea typeface="Helvetica Neue"/>
+                <a:cs typeface="Helvetica Neue"/>
+              </a:defRPr>
+            </a:pPr>
+            <a:r>
+              <a:rPr sz="1500">
+                <a:solidFill>
+                  <a:srgbClr val="000000"/>
+                </a:solidFill>
+                <a:latin typeface="Helvetica Neue"/>
+                <a:ea typeface="Helvetica Neue"/>
+                <a:cs typeface="Helvetica Neue"/>
+              </a:rPr>
+              <a:t>денежные оценки масштабируются через текущую базу</a:t>
+            </a:r>
+          </a:p>
+        </p:txBody>
+      </p:sp>
+      <p:sp>
+        <p:nvSpPr>
+          <p:cNvPr id="9" name="slide2-panel-3">
+            <a:extLst xmlns:a="http://schemas.openxmlformats.org/drawingml/2006/main">
+              <a:ext uri="{FF2B5EF4-FFF2-40B4-BE49-F238E27FC236}">
+                <a16:creationId xmlns:a16="http://schemas.microsoft.com/office/drawing/2014/main" id="{CAA7C704-AE6E-42D6-B948-0D90C2ECDCCC}"/>
+              </a:ext>
+            </a:extLst>
+          </p:cNvPr>
+          <p:cNvSpPr>
+            <a:spLocks xmlns:a="http://schemas.openxmlformats.org/drawingml/2006/main" noGrp="1"/>
+          </p:cNvSpPr>
+          <p:nvPr/>
+        </p:nvSpPr>
+        <p:spPr>
+          <a:xfrm xmlns:a="http://schemas.openxmlformats.org/drawingml/2006/main">
+            <a:off x="6267450" y="4514850"/>
+            <a:ext cx="5534025" cy="1428750"/>
+          </a:xfrm>
+          <a:prstGeom xmlns:a="http://schemas.openxmlformats.org/drawingml/2006/main" prst="rect">
+            <a:avLst/>
+          </a:prstGeom>
+          <a:solidFill xmlns:a="http://schemas.openxmlformats.org/drawingml/2006/main">
+            <a:srgbClr val="F2F2F2"/>
+          </a:solidFill>
+          <a:ln xmlns:a="http://schemas.openxmlformats.org/drawingml/2006/main" w="0">
+            <a:solidFill>
+              <a:srgbClr val="F2F2F2"/>
+            </a:solidFill>
+            <a:prstDash val="solid"/>
+          </a:ln>
+        </p:spPr>
+      </p:sp>
+      <p:sp>
+        <p:nvSpPr>
+          <p:cNvPr id="10" name="slide2-stat-3">
+            <a:extLst xmlns:a="http://schemas.openxmlformats.org/drawingml/2006/main">
+              <a:ext uri="{FF2B5EF4-FFF2-40B4-BE49-F238E27FC236}">
+                <a16:creationId xmlns:a16="http://schemas.microsoft.com/office/drawing/2014/main" id="{673C395B-47FB-4484-9655-08277FFE8D3B}"/>
+              </a:ext>
+            </a:extLst>
+          </p:cNvPr>
+          <p:cNvSpPr>
+            <a:spLocks xmlns:a="http://schemas.openxmlformats.org/drawingml/2006/main" noGrp="1"/>
+          </p:cNvSpPr>
+          <p:nvPr/>
+        </p:nvSpPr>
+        <p:spPr>
+          <a:xfrm xmlns:a="http://schemas.openxmlformats.org/drawingml/2006/main">
+            <a:off x="6572250" y="4733925"/>
+            <a:ext cx="4905375" cy="457200"/>
+          </a:xfrm>
+          <a:prstGeom xmlns:a="http://schemas.openxmlformats.org/drawingml/2006/main" prst="rect">
+            <a:avLst/>
+          </a:prstGeom>
+          <a:noFill xmlns:a="http://schemas.openxmlformats.org/drawingml/2006/main"/>
+          <a:ln xmlns:a="http://schemas.openxmlformats.org/drawingml/2006/main" w="0">
+            <a:noFill/>
+            <a:prstDash val="solid"/>
+          </a:ln>
+        </p:spPr>
+        <p:txBody>
+          <a:bodyPr xmlns:a="http://schemas.openxmlformats.org/drawingml/2006/main" anchor="t"/>
+          <a:lstStyle xmlns:a="http://schemas.openxmlformats.org/drawingml/2006/main"/>
+          <a:p xmlns:a="http://schemas.openxmlformats.org/drawingml/2006/main">
+            <a:pPr>
+              <a:buNone/>
+              <a:defRPr sz="2400" b="1">
+                <a:solidFill>
+                  <a:srgbClr val="1769E0"/>
+                </a:solidFill>
+                <a:latin typeface="Helvetica Neue"/>
+                <a:ea typeface="Helvetica Neue"/>
+                <a:cs typeface="Helvetica Neue"/>
+              </a:defRPr>
+            </a:pPr>
+            <a:r>
+              <a:rPr sz="2400" b="1">
+                <a:solidFill>
+                  <a:srgbClr val="1769E0"/>
+                </a:solidFill>
+                <a:latin typeface="Helvetica Neue"/>
+                <a:ea typeface="Helvetica Neue"/>
+                <a:cs typeface="Helvetica Neue"/>
+              </a:rPr>
+              <a:t>config + tests</a:t>
+            </a:r>
+          </a:p>
+        </p:txBody>
+      </p:sp>
+      <p:sp>
+        <p:nvSpPr>
+          <p:cNvPr id="11" name="slide2-label-3">
+            <a:extLst xmlns:a="http://schemas.openxmlformats.org/drawingml/2006/main">
+              <a:ext uri="{FF2B5EF4-FFF2-40B4-BE49-F238E27FC236}">
+                <a16:creationId xmlns:a16="http://schemas.microsoft.com/office/drawing/2014/main" id="{7D5A923D-CF74-437E-890D-28540BE621DC}"/>
+              </a:ext>
+            </a:extLst>
+          </p:cNvPr>
+          <p:cNvSpPr>
+            <a:spLocks xmlns:a="http://schemas.openxmlformats.org/drawingml/2006/main" noGrp="1"/>
+          </p:cNvSpPr>
+          <p:nvPr/>
+        </p:nvSpPr>
+        <p:spPr>
+          <a:xfrm xmlns:a="http://schemas.openxmlformats.org/drawingml/2006/main">
+            <a:off x="6572250" y="5267325"/>
+            <a:ext cx="4905375" cy="523875"/>
+          </a:xfrm>
+          <a:prstGeom xmlns:a="http://schemas.openxmlformats.org/drawingml/2006/main" prst="rect">
+            <a:avLst/>
+          </a:prstGeom>
+          <a:noFill xmlns:a="http://schemas.openxmlformats.org/drawingml/2006/main"/>
+          <a:ln xmlns:a="http://schemas.openxmlformats.org/drawingml/2006/main" w="0">
+            <a:noFill/>
+            <a:prstDash val="solid"/>
+          </a:ln>
+        </p:spPr>
+        <p:txBody>
+          <a:bodyPr xmlns:a="http://schemas.openxmlformats.org/drawingml/2006/main" anchor="t"/>
+          <a:lstStyle xmlns:a="http://schemas.openxmlformats.org/drawingml/2006/main"/>
+          <a:p xmlns:a="http://schemas.openxmlformats.org/drawingml/2006/main">
+            <a:pPr>
+              <a:buNone/>
+              <a:defRPr sz="1500">
+                <a:solidFill>
+                  <a:srgbClr val="000000"/>
+                </a:solidFill>
+                <a:latin typeface="Helvetica Neue"/>
+                <a:ea typeface="Helvetica Neue"/>
+                <a:cs typeface="Helvetica Neue"/>
+              </a:defRPr>
+            </a:pPr>
+            <a:r>
+              <a:rPr sz="1500">
+                <a:solidFill>
+                  <a:srgbClr val="000000"/>
+                </a:solidFill>
+                <a:latin typeface="Helvetica Neue"/>
+                <a:ea typeface="Helvetica Neue"/>
+                <a:cs typeface="Helvetica Neue"/>
+              </a:rPr>
+              <a:t>допущения вынесены отдельно, расчёты проверяются автоматически</a:t>
+            </a:r>
+          </a:p>
+        </p:txBody>
+      </p:sp>
+      <p:sp>
+        <p:nvSpPr>
+          <p:cNvPr id="12" name="source-2">
+            <a:extLst xmlns:a="http://schemas.openxmlformats.org/drawingml/2006/main">
+              <a:ext uri="{FF2B5EF4-FFF2-40B4-BE49-F238E27FC236}">
+                <a16:creationId xmlns:a16="http://schemas.microsoft.com/office/drawing/2014/main" id="{53E3A59F-FBEC-410F-A0AC-E643AAAE0B53}"/>
+              </a:ext>
+            </a:extLst>
+          </p:cNvPr>
+          <p:cNvSpPr>
+            <a:spLocks xmlns:a="http://schemas.openxmlformats.org/drawingml/2006/main" noGrp="1"/>
+          </p:cNvSpPr>
+          <p:nvPr/>
+        </p:nvSpPr>
+        <p:spPr>
+          <a:xfrm xmlns:a="http://schemas.openxmlformats.org/drawingml/2006/main">
+            <a:off x="400050" y="6429375"/>
+            <a:ext cx="9620250" cy="209550"/>
+          </a:xfrm>
+          <a:prstGeom xmlns:a="http://schemas.openxmlformats.org/drawingml/2006/main" prst="rect">
+            <a:avLst/>
+          </a:prstGeom>
+          <a:noFill xmlns:a="http://schemas.openxmlformats.org/drawingml/2006/main"/>
+          <a:ln xmlns:a="http://schemas.openxmlformats.org/drawingml/2006/main" w="0">
+            <a:noFill/>
+            <a:prstDash val="solid"/>
+          </a:ln>
+        </p:spPr>
+        <p:txBody>
+          <a:bodyPr xmlns:a="http://schemas.openxmlformats.org/drawingml/2006/main" anchor="t"/>
+          <a:lstStyle xmlns:a="http://schemas.openxmlformats.org/drawingml/2006/main"/>
+          <a:p xmlns:a="http://schemas.openxmlformats.org/drawingml/2006/main">
+            <a:pPr>
+              <a:buNone/>
+              <a:defRPr sz="975">
+                <a:solidFill>
+                  <a:srgbClr val="666666"/>
+                </a:solidFill>
+                <a:latin typeface="Helvetica Neue"/>
+                <a:ea typeface="Helvetica Neue"/>
+                <a:cs typeface="Helvetica Neue"/>
+              </a:defRPr>
+            </a:pPr>
+            <a:r>
+              <a:rPr sz="975">
+                <a:solidFill>
+                  <a:srgbClr val="666666"/>
+                </a:solidFill>
+                <a:latin typeface="Helvetica Neue"/>
+                <a:ea typeface="Helvetica Neue"/>
+                <a:cs typeface="Helvetica Neue"/>
+              </a:rPr>
+              <a:t>Источник: ограничения и структура проекта из README</a:t>
+            </a:r>
+          </a:p>
+        </p:txBody>
+      </p:sp>
+      <p:sp>
+        <p:nvSpPr>
+          <p:cNvPr id="13" name="page-2">
+            <a:extLst xmlns:a="http://schemas.openxmlformats.org/drawingml/2006/main">
+              <a:ext uri="{FF2B5EF4-FFF2-40B4-BE49-F238E27FC236}">
+                <a16:creationId xmlns:a16="http://schemas.microsoft.com/office/drawing/2014/main" id="{8FE0F372-C976-48A4-AA0C-B065922FD4B4}"/>
+              </a:ext>
+            </a:extLst>
+          </p:cNvPr>
+          <p:cNvSpPr>
+            <a:spLocks xmlns:a="http://schemas.openxmlformats.org/drawingml/2006/main" noGrp="1"/>
+          </p:cNvSpPr>
+          <p:nvPr/>
+        </p:nvSpPr>
+        <p:spPr>
+          <a:xfrm xmlns:a="http://schemas.openxmlformats.org/drawingml/2006/main">
+            <a:off x="11277600" y="6381750"/>
+            <a:ext cx="523875" cy="209550"/>
+          </a:xfrm>
+          <a:prstGeom xmlns:a="http://schemas.openxmlformats.org/drawingml/2006/main" prst="rect">
+            <a:avLst/>
+          </a:prstGeom>
+          <a:noFill xmlns:a="http://schemas.openxmlformats.org/drawingml/2006/main"/>
+          <a:ln xmlns:a="http://schemas.openxmlformats.org/drawingml/2006/main" w="0">
+            <a:noFill/>
+            <a:prstDash val="solid"/>
+          </a:ln>
+        </p:spPr>
+        <p:txBody>
+          <a:bodyPr xmlns:a="http://schemas.openxmlformats.org/drawingml/2006/main" anchor="t"/>
+          <a:lstStyle xmlns:a="http://schemas.openxmlformats.org/drawingml/2006/main"/>
+          <a:p xmlns:a="http://schemas.openxmlformats.org/drawingml/2006/main">
+            <a:pPr algn="r">
+              <a:buNone/>
+              <a:defRPr sz="975">
+                <a:solidFill>
+                  <a:srgbClr val="444444"/>
+                </a:solidFill>
+                <a:latin typeface="Helvetica Neue"/>
+                <a:ea typeface="Helvetica Neue"/>
+                <a:cs typeface="Helvetica Neue"/>
+              </a:defRPr>
+            </a:pPr>
+            <a:r>
+              <a:rPr sz="975">
+                <a:solidFill>
+                  <a:srgbClr val="444444"/>
+                </a:solidFill>
+                <a:latin typeface="Helvetica Neue"/>
+                <a:ea typeface="Helvetica Neue"/>
+                <a:cs typeface="Helvetica Neue"/>
+              </a:rPr>
+              <a:t>4</a:t>
             </a:r>
           </a:p>
         </p:txBody>

</xml_diff>

<commit_message>
Replace README slides with text-only version
</commit_message>
<xml_diff>
--- a/outputs/bank_roi_presentation_ru.pptx
+++ b/outputs/bank_roi_presentation_ru.pptx
@@ -2,16 +2,16 @@
 <file path=ppt/presentation.xml><?xml version="1.0" encoding="utf-8"?>
 <p:presentation xmlns:p="http://schemas.openxmlformats.org/presentationml/2006/main">
   <p:sldMasterIdLst>
-    <p:sldMasterId xmlns:r="http://schemas.openxmlformats.org/officeDocument/2006/relationships" id="2147483648" r:id="Redd06cf0fe3e48d1"/>
+    <p:sldMasterId xmlns:r="http://schemas.openxmlformats.org/officeDocument/2006/relationships" id="2147483648" r:id="Rba76a565157d43ad"/>
   </p:sldMasterIdLst>
   <p:notesMasterIdLst>
-    <p:notesMasterId xmlns:r="http://schemas.openxmlformats.org/officeDocument/2006/relationships" r:id="R916098676ba1429c"/>
+    <p:notesMasterId xmlns:r="http://schemas.openxmlformats.org/officeDocument/2006/relationships" r:id="R269195c192074164"/>
   </p:notesMasterIdLst>
   <p:sldIdLst>
-    <p:sldId xmlns:r="http://schemas.openxmlformats.org/officeDocument/2006/relationships" id="256" r:id="R631839c1024e4a75"/>
-    <p:sldId xmlns:r="http://schemas.openxmlformats.org/officeDocument/2006/relationships" id="257" r:id="Ra9d6a4e8d24142a5"/>
-    <p:sldId xmlns:r="http://schemas.openxmlformats.org/officeDocument/2006/relationships" id="258" r:id="Re7d8b66d6cb64c2f"/>
-    <p:sldId xmlns:r="http://schemas.openxmlformats.org/officeDocument/2006/relationships" id="259" r:id="Rbfc57193ed214d11"/>
+    <p:sldId xmlns:r="http://schemas.openxmlformats.org/officeDocument/2006/relationships" id="256" r:id="Rf6eadf1edf6d4eb2"/>
+    <p:sldId xmlns:r="http://schemas.openxmlformats.org/officeDocument/2006/relationships" id="257" r:id="R3a02902de46a4f26"/>
+    <p:sldId xmlns:r="http://schemas.openxmlformats.org/officeDocument/2006/relationships" id="258" r:id="Rc73b82c01c4f4eb9"/>
+    <p:sldId xmlns:r="http://schemas.openxmlformats.org/officeDocument/2006/relationships" id="259" r:id="Rd78a8d3f55504b23"/>
   </p:sldIdLst>
   <p:sldSz cx="12192000" cy="6858000"/>
   <p:notesSz cx="6858000" cy="9144000"/>
@@ -635,11 +635,6 @@
           </a:p>
           <a:p xmlns:a="http://schemas.openxmlformats.org/drawingml/2006/main">
             <a:r>
-              <a:t>- /Users/alexandra/Documents/Codex/2026-08-09/yt/data/processed/tableau_tenure_curve.csv</a:t>
-            </a:r>
-          </a:p>
-          <a:p xmlns:a="http://schemas.openxmlformats.org/drawingml/2006/main">
-            <a:r>
               <a:t>- https://github.com/alexsoldatova/bank-roi-tableau-dashboard</a:t>
             </a:r>
           </a:p>
@@ -721,16 +716,6 @@
           <a:p xmlns:a="http://schemas.openxmlformats.org/drawingml/2006/main">
             <a:r>
               <a:t>- /Users/alexandra/Documents/Codex/2026-08-09/yt/README.md</a:t>
-            </a:r>
-          </a:p>
-          <a:p xmlns:a="http://schemas.openxmlformats.org/drawingml/2006/main">
-            <a:r>
-              <a:t>- /Users/alexandra/Documents/Codex/2026-08-09/yt/config/assumptions.json</a:t>
-            </a:r>
-          </a:p>
-          <a:p xmlns:a="http://schemas.openxmlformats.org/drawingml/2006/main">
-            <a:r>
-              <a:t>- /Users/alexandra/Documents/Codex/2026-08-09/yt/tests</a:t>
             </a:r>
           </a:p>
           <a:p xmlns:a="http://schemas.openxmlformats.org/drawingml/2006/main">
@@ -808,7 +793,7 @@
   </p:cSld>
   <p:clrMap bg1="lt1" tx1="dk1" bg2="lt2" tx2="dk2" accent1="accent1" accent2="accent2" accent3="accent3" accent4="accent4" accent5="accent5" accent6="accent6" hlink="hlink" folHlink="folHlink"/>
   <p:sldLayoutIdLst>
-    <p:sldLayoutId xmlns:r="http://schemas.openxmlformats.org/officeDocument/2006/relationships" id="2147483649" r:id="R359ff6d82ddb4368"/>
+    <p:sldLayoutId xmlns:r="http://schemas.openxmlformats.org/officeDocument/2006/relationships" id="2147483649" r:id="R2e189ba4365f4e79"/>
   </p:sldLayoutIdLst>
   <p:txStyles>
     <p:titleStyle>
@@ -1966,7 +1951,7 @@
           <c:idx val="0"/>
           <c:order val="0"/>
           <c:tx>
-            <c:v>Счёт открыт</c:v>
+            <c:v>Открытые счета</c:v>
           </c:tx>
           <c:spPr>
             <a:solidFill xmlns:a="http://schemas.openxmlformats.org/drawingml/2006/main">
@@ -1975,48 +1960,60 @@
           </c:spPr>
           <c:cat>
             <c:strLit>
-              <c:ptCount val="6"/>
+              <c:ptCount val="8"/>
               <c:pt idx="0">
-                <c:v>0 мес.</c:v>
+                <c:v>янв 24</c:v>
               </c:pt>
               <c:pt idx="1">
-                <c:v>6 мес.</c:v>
+                <c:v>май 24</c:v>
               </c:pt>
               <c:pt idx="2">
-                <c:v>12 мес.</c:v>
+                <c:v>сен 24</c:v>
               </c:pt>
               <c:pt idx="3">
-                <c:v>18 мес.</c:v>
+                <c:v>янв 25</c:v>
               </c:pt>
               <c:pt idx="4">
-                <c:v>24 мес.</c:v>
+                <c:v>май 25</c:v>
               </c:pt>
               <c:pt idx="5">
-                <c:v>28 мес.</c:v>
+                <c:v>сен 25</c:v>
+              </c:pt>
+              <c:pt idx="6">
+                <c:v>янв 26</c:v>
+              </c:pt>
+              <c:pt idx="7">
+                <c:v>май 26</c:v>
               </c:pt>
             </c:strLit>
           </c:cat>
           <c:val>
             <c:numLit>
               <c:formatCode>0</c:formatCode>
-              <c:ptCount val="6"/>
+              <c:ptCount val="8"/>
               <c:pt idx="0">
-                <c:v>1</c:v>
+                <c:v>507</c:v>
               </c:pt>
               <c:pt idx="1">
-                <c:v>0.8831728966120765</c:v>
+                <c:v>2968</c:v>
               </c:pt>
               <c:pt idx="2">
-                <c:v>0.7989358963357075</c:v>
+                <c:v>5208</c:v>
               </c:pt>
               <c:pt idx="3">
-                <c:v>0.7221917808219178</c:v>
+                <c:v>7906</c:v>
               </c:pt>
               <c:pt idx="4">
-                <c:v>0.6524547803617571</c:v>
+                <c:v>10048</c:v>
               </c:pt>
               <c:pt idx="5">
-                <c:v>0.6548323471400395</c:v>
+                <c:v>12110</c:v>
+              </c:pt>
+              <c:pt idx="6">
+                <c:v>14270</c:v>
+              </c:pt>
+              <c:pt idx="7">
+                <c:v>15876</c:v>
               </c:pt>
             </c:numLit>
           </c:val>
@@ -2025,7 +2022,7 @@
           <c:idx val="1"/>
           <c:order val="1"/>
           <c:tx>
-            <c:v>Счёт активен</c:v>
+            <c:v>Активные счета</c:v>
           </c:tx>
           <c:spPr>
             <a:solidFill xmlns:a="http://schemas.openxmlformats.org/drawingml/2006/main">
@@ -2034,48 +2031,60 @@
           </c:spPr>
           <c:cat>
             <c:strLit>
-              <c:ptCount val="6"/>
+              <c:ptCount val="8"/>
               <c:pt idx="0">
-                <c:v>0 мес.</c:v>
+                <c:v>янв 24</c:v>
               </c:pt>
               <c:pt idx="1">
-                <c:v>6 мес.</c:v>
+                <c:v>май 24</c:v>
               </c:pt>
               <c:pt idx="2">
-                <c:v>12 мес.</c:v>
+                <c:v>сен 24</c:v>
               </c:pt>
               <c:pt idx="3">
-                <c:v>18 мес.</c:v>
+                <c:v>янв 25</c:v>
               </c:pt>
               <c:pt idx="4">
-                <c:v>24 мес.</c:v>
+                <c:v>май 25</c:v>
               </c:pt>
               <c:pt idx="5">
-                <c:v>28 мес.</c:v>
+                <c:v>сен 25</c:v>
+              </c:pt>
+              <c:pt idx="6">
+                <c:v>янв 26</c:v>
+              </c:pt>
+              <c:pt idx="7">
+                <c:v>май 26</c:v>
               </c:pt>
             </c:strLit>
           </c:cat>
           <c:val>
             <c:numLit>
               <c:formatCode>0</c:formatCode>
-              <c:ptCount val="6"/>
+              <c:ptCount val="8"/>
               <c:pt idx="0">
-                <c:v>0.5658136645962732</c:v>
+                <c:v>266</c:v>
               </c:pt>
               <c:pt idx="1">
-                <c:v>0.5957619702462807</c:v>
+                <c:v>1981</c:v>
               </c:pt>
               <c:pt idx="2">
-                <c:v>0.5270745730713121</c:v>
+                <c:v>3581</c:v>
               </c:pt>
               <c:pt idx="3">
-                <c:v>0.4626027397260274</c:v>
+                <c:v>5241</c:v>
               </c:pt>
               <c:pt idx="4">
-                <c:v>0.3875968992248062</c:v>
+                <c:v>6635</c:v>
               </c:pt>
               <c:pt idx="5">
-                <c:v>0.41222879684418146</c:v>
+                <c:v>7953</c:v>
+              </c:pt>
+              <c:pt idx="6">
+                <c:v>9077</c:v>
+              </c:pt>
+              <c:pt idx="7">
+                <c:v>10279</c:v>
               </c:pt>
             </c:numLit>
           </c:val>
@@ -2130,7 +2139,7 @@
         <c:axId val="48672768"/>
         <c:scaling>
           <c:orientation val="minMax"/>
-          <c:max val="1"/>
+          <c:max val="22000"/>
           <c:min val="0"/>
         </c:scaling>
         <c:delete val="0"/>
@@ -2145,7 +2154,7 @@
             </a:ln>
           </c:spPr>
         </c:majorGridlines>
-        <c:numFmt formatCode="0%"/>
+        <c:numFmt formatCode="#,##0"/>
         <c:majorTickMark val="none"/>
         <c:minorTickMark val="none"/>
         <c:spPr>
@@ -2171,7 +2180,7 @@
         </c:txPr>
         <c:crossAx val="48650112"/>
         <c:crossBetween val="between"/>
-        <c:majorUnit val="0.2"/>
+        <c:majorUnit val="5000"/>
       </c:valAx>
       <c:spPr>
         <a:noFill xmlns:a="http://schemas.openxmlformats.org/drawingml/2006/main"/>
@@ -2229,7 +2238,7 @@
           <c:idx val="0"/>
           <c:order val="0"/>
           <c:tx>
-            <c:v>Ожидаемые месяцы</c:v>
+            <c:v>Открытые счета</c:v>
           </c:tx>
           <c:spPr>
             <a:solidFill xmlns:a="http://schemas.openxmlformats.org/drawingml/2006/main">
@@ -2238,24 +2247,60 @@
           </c:spPr>
           <c:cat>
             <c:strLit>
-              <c:ptCount val="2"/>
+              <c:ptCount val="8"/>
               <c:pt idx="0">
-                <c:v>Активные</c:v>
+                <c:v>янв 24</c:v>
               </c:pt>
               <c:pt idx="1">
-                <c:v>Открытые</c:v>
+                <c:v>май 24</c:v>
+              </c:pt>
+              <c:pt idx="2">
+                <c:v>сен 24</c:v>
+              </c:pt>
+              <c:pt idx="3">
+                <c:v>янв 25</c:v>
+              </c:pt>
+              <c:pt idx="4">
+                <c:v>май 25</c:v>
+              </c:pt>
+              <c:pt idx="5">
+                <c:v>сен 25</c:v>
+              </c:pt>
+              <c:pt idx="6">
+                <c:v>янв 26</c:v>
+              </c:pt>
+              <c:pt idx="7">
+                <c:v>май 26</c:v>
               </c:pt>
             </c:strLit>
           </c:cat>
           <c:val>
             <c:numLit>
-              <c:formatCode>0.0</c:formatCode>
-              <c:ptCount val="2"/>
+              <c:formatCode>0</c:formatCode>
+              <c:ptCount val="8"/>
               <c:pt idx="0">
-                <c:v>14.7342</c:v>
+                <c:v>507</c:v>
               </c:pt>
               <c:pt idx="1">
-                <c:v>22.7496</c:v>
+                <c:v>2968</c:v>
+              </c:pt>
+              <c:pt idx="2">
+                <c:v>5208</c:v>
+              </c:pt>
+              <c:pt idx="3">
+                <c:v>7906</c:v>
+              </c:pt>
+              <c:pt idx="4">
+                <c:v>10048</c:v>
+              </c:pt>
+              <c:pt idx="5">
+                <c:v>12110</c:v>
+              </c:pt>
+              <c:pt idx="6">
+                <c:v>14270</c:v>
+              </c:pt>
+              <c:pt idx="7">
+                <c:v>15876</c:v>
               </c:pt>
             </c:numLit>
           </c:val>
@@ -2264,7 +2309,7 @@
           <c:idx val="1"/>
           <c:order val="1"/>
           <c:tx>
-            <c:v>Предел наблюдения</c:v>
+            <c:v>Активные счета</c:v>
           </c:tx>
           <c:spPr>
             <a:solidFill xmlns:a="http://schemas.openxmlformats.org/drawingml/2006/main">
@@ -2273,31 +2318,67 @@
           </c:spPr>
           <c:cat>
             <c:strLit>
-              <c:ptCount val="2"/>
+              <c:ptCount val="8"/>
               <c:pt idx="0">
-                <c:v>Активные</c:v>
+                <c:v>янв 24</c:v>
               </c:pt>
               <c:pt idx="1">
-                <c:v>Открытые</c:v>
+                <c:v>май 24</c:v>
+              </c:pt>
+              <c:pt idx="2">
+                <c:v>сен 24</c:v>
+              </c:pt>
+              <c:pt idx="3">
+                <c:v>янв 25</c:v>
+              </c:pt>
+              <c:pt idx="4">
+                <c:v>май 25</c:v>
+              </c:pt>
+              <c:pt idx="5">
+                <c:v>сен 25</c:v>
+              </c:pt>
+              <c:pt idx="6">
+                <c:v>янв 26</c:v>
+              </c:pt>
+              <c:pt idx="7">
+                <c:v>май 26</c:v>
               </c:pt>
             </c:strLit>
           </c:cat>
           <c:val>
             <c:numLit>
-              <c:formatCode>0.0</c:formatCode>
-              <c:ptCount val="2"/>
+              <c:formatCode>0</c:formatCode>
+              <c:ptCount val="8"/>
               <c:pt idx="0">
-                <c:v>29</c:v>
+                <c:v>266</c:v>
               </c:pt>
               <c:pt idx="1">
-                <c:v>29</c:v>
+                <c:v>1981</c:v>
+              </c:pt>
+              <c:pt idx="2">
+                <c:v>3581</c:v>
+              </c:pt>
+              <c:pt idx="3">
+                <c:v>5241</c:v>
+              </c:pt>
+              <c:pt idx="4">
+                <c:v>6635</c:v>
+              </c:pt>
+              <c:pt idx="5">
+                <c:v>7953</c:v>
+              </c:pt>
+              <c:pt idx="6">
+                <c:v>9077</c:v>
+              </c:pt>
+              <c:pt idx="7">
+                <c:v>10279</c:v>
               </c:pt>
             </c:numLit>
           </c:val>
         </c:ser>
         <c:dLbls>
           <c:showLegendKey val="0"/>
-          <c:showVal val="1"/>
+          <c:showVal val="0"/>
           <c:showCatName val="0"/>
           <c:showSerName val="0"/>
           <c:showPercent val="0"/>
@@ -2345,7 +2426,7 @@
         <c:axId val="48672768"/>
         <c:scaling>
           <c:orientation val="minMax"/>
-          <c:max val="30"/>
+          <c:max val="22000"/>
           <c:min val="0"/>
         </c:scaling>
         <c:delete val="0"/>
@@ -2360,7 +2441,7 @@
             </a:ln>
           </c:spPr>
         </c:majorGridlines>
-        <c:numFmt formatCode="0"/>
+        <c:numFmt formatCode="#,##0"/>
         <c:majorTickMark val="none"/>
         <c:minorTickMark val="none"/>
         <c:spPr>
@@ -2386,7 +2467,7 @@
         </c:txPr>
         <c:crossAx val="48650112"/>
         <c:crossBetween val="between"/>
-        <c:majorUnit val="5"/>
+        <c:majorUnit val="5000"/>
       </c:valAx>
       <c:spPr>
         <a:noFill xmlns:a="http://schemas.openxmlformats.org/drawingml/2006/main"/>
@@ -2576,7 +2657,7 @@
         </p:xfrm>
         <a:graphic xmlns:a="http://schemas.openxmlformats.org/drawingml/2006/main">
           <a:graphicData uri="http://schemas.openxmlformats.org/drawingml/2006/chart">
-            <c:chart xmlns:r="http://schemas.openxmlformats.org/officeDocument/2006/relationships" xmlns:c="http://schemas.openxmlformats.org/drawingml/2006/chart" r:id="Re31ebe76e4d94b2e"/>
+            <c:chart xmlns:r="http://schemas.openxmlformats.org/officeDocument/2006/relationships" xmlns:c="http://schemas.openxmlformats.org/drawingml/2006/chart" r:id="R0bd109b349c94a9f"/>
           </a:graphicData>
         </a:graphic>
       </p:graphicFrame>
@@ -3143,7 +3224,7 @@
         </p:xfrm>
         <a:graphic xmlns:a="http://schemas.openxmlformats.org/drawingml/2006/main">
           <a:graphicData uri="http://schemas.openxmlformats.org/drawingml/2006/chart">
-            <c:chart xmlns:r="http://schemas.openxmlformats.org/officeDocument/2006/relationships" xmlns:c="http://schemas.openxmlformats.org/drawingml/2006/chart" r:id="Reff25a675a3d4686"/>
+            <c:chart xmlns:r="http://schemas.openxmlformats.org/officeDocument/2006/relationships" xmlns:c="http://schemas.openxmlformats.org/drawingml/2006/chart" r:id="R2761a1a36f0c4d28"/>
           </a:graphicData>
         </a:graphic>
       </p:graphicFrame>
@@ -3783,7 +3864,7 @@
                 <a:ea typeface="Helvetica Neue"/>
                 <a:cs typeface="Helvetica Neue"/>
               </a:rPr>
-              <a:t>Методика учитывает возраст счёта</a:t>
+              <a:t>Окупаемость банка</a:t>
             </a:r>
           </a:p>
         </p:txBody>
@@ -3795,48 +3876,15 @@
           <p:nvPr/>
         </p:nvGraphicFramePr>
         <p:xfrm>
-          <a:off xmlns:a="http://schemas.openxmlformats.org/drawingml/2006/main" x="381000" y="1200150"/>
-          <a:ext xmlns:a="http://schemas.openxmlformats.org/drawingml/2006/main" cx="5524500" cy="5000625"/>
+          <a:off xmlns:a="http://schemas.openxmlformats.org/drawingml/2006/main" x="-19050000" y="-19050000"/>
+          <a:ext xmlns:a="http://schemas.openxmlformats.org/drawingml/2006/main" cx="9525" cy="9525"/>
         </p:xfrm>
         <a:graphic xmlns:a="http://schemas.openxmlformats.org/drawingml/2006/main">
           <a:graphicData uri="http://schemas.openxmlformats.org/drawingml/2006/chart">
-            <c:chart xmlns:r="http://schemas.openxmlformats.org/officeDocument/2006/relationships" xmlns:c="http://schemas.openxmlformats.org/drawingml/2006/chart" r:id="R8a62830263394edc"/>
+            <c:chart xmlns:r="http://schemas.openxmlformats.org/officeDocument/2006/relationships" xmlns:c="http://schemas.openxmlformats.org/drawingml/2006/chart" r:id="R25f33aafa10649c6"/>
           </a:graphicData>
         </a:graphic>
       </p:graphicFrame>
-      <p:sp>
-        <p:nvSpPr>
-          <p:cNvPr id="3" name="slide2-panel-1">
-            <a:extLst xmlns:a="http://schemas.openxmlformats.org/drawingml/2006/main">
-              <a:ext uri="{FF2B5EF4-FFF2-40B4-BE49-F238E27FC236}">
-                <a16:creationId xmlns:a16="http://schemas.microsoft.com/office/drawing/2014/main" id="{71BE8BF3-4117-437F-A07F-9FDA57505565}"/>
-              </a:ext>
-            </a:extLst>
-          </p:cNvPr>
-          <p:cNvSpPr>
-            <a:spLocks xmlns:a="http://schemas.openxmlformats.org/drawingml/2006/main" noGrp="1"/>
-          </p:cNvSpPr>
-          <p:nvPr/>
-        </p:nvSpPr>
-        <p:spPr>
-          <a:xfrm xmlns:a="http://schemas.openxmlformats.org/drawingml/2006/main">
-            <a:off x="6267450" y="1200150"/>
-            <a:ext cx="5534025" cy="1428750"/>
-          </a:xfrm>
-          <a:prstGeom xmlns:a="http://schemas.openxmlformats.org/drawingml/2006/main" prst="rect">
-            <a:avLst/>
-          </a:prstGeom>
-          <a:solidFill xmlns:a="http://schemas.openxmlformats.org/drawingml/2006/main">
-            <a:srgbClr val="F2F2F2"/>
-          </a:solidFill>
-          <a:ln xmlns:a="http://schemas.openxmlformats.org/drawingml/2006/main" w="0">
-            <a:solidFill>
-              <a:srgbClr val="F2F2F2"/>
-            </a:solidFill>
-            <a:prstDash val="solid"/>
-          </a:ln>
-        </p:spPr>
-      </p:sp>
       <p:sp>
         <p:nvSpPr>
           <p:cNvPr id="4" name="slide2-stat-1">
@@ -3853,8 +3901,8 @@
         </p:nvSpPr>
         <p:spPr>
           <a:xfrm xmlns:a="http://schemas.openxmlformats.org/drawingml/2006/main">
-            <a:off x="6572250" y="1419225"/>
-            <a:ext cx="4905375" cy="457200"/>
+            <a:off x="400050" y="1162050"/>
+            <a:ext cx="11391900" cy="419100"/>
           </a:xfrm>
           <a:prstGeom xmlns:a="http://schemas.openxmlformats.org/drawingml/2006/main" prst="rect">
             <a:avLst/>
@@ -3889,7 +3937,7 @@
                 <a:ea typeface="Helvetica Neue"/>
                 <a:cs typeface="Helvetica Neue"/>
               </a:rPr>
-              <a:t>Счёт</a:t>
+              <a:t>Воспроизводимое решение</a:t>
             </a:r>
           </a:p>
         </p:txBody>
@@ -3910,8 +3958,8 @@
         </p:nvSpPr>
         <p:spPr>
           <a:xfrm xmlns:a="http://schemas.openxmlformats.org/drawingml/2006/main">
-            <a:off x="6572250" y="1952625"/>
-            <a:ext cx="4905375" cy="523875"/>
+            <a:off x="400050" y="1609725"/>
+            <a:ext cx="11391900" cy="590550"/>
           </a:xfrm>
           <a:prstGeom xmlns:a="http://schemas.openxmlformats.org/drawingml/2006/main" prst="rect">
             <a:avLst/>
@@ -3946,43 +3994,10 @@
                 <a:ea typeface="Helvetica Neue"/>
                 <a:cs typeface="Helvetica Neue"/>
               </a:rPr>
-              <a:t>единица анализа: CLIENT_ID + OPEN_DATE</a:t>
+              <a:t>Проверка клиентской активности, когортная модель, юнит-экономика и сценарный график окупаемости от среднего остатка.</a:t>
             </a:r>
           </a:p>
         </p:txBody>
-      </p:sp>
-      <p:sp>
-        <p:nvSpPr>
-          <p:cNvPr id="6" name="slide2-panel-2">
-            <a:extLst xmlns:a="http://schemas.openxmlformats.org/drawingml/2006/main">
-              <a:ext uri="{FF2B5EF4-FFF2-40B4-BE49-F238E27FC236}">
-                <a16:creationId xmlns:a16="http://schemas.microsoft.com/office/drawing/2014/main" id="{2967ABD8-699E-4E8D-88EB-E248FD0C86A2}"/>
-              </a:ext>
-            </a:extLst>
-          </p:cNvPr>
-          <p:cNvSpPr>
-            <a:spLocks xmlns:a="http://schemas.openxmlformats.org/drawingml/2006/main" noGrp="1"/>
-          </p:cNvSpPr>
-          <p:nvPr/>
-        </p:nvSpPr>
-        <p:spPr>
-          <a:xfrm xmlns:a="http://schemas.openxmlformats.org/drawingml/2006/main">
-            <a:off x="6267450" y="2857500"/>
-            <a:ext cx="5534025" cy="1428750"/>
-          </a:xfrm>
-          <a:prstGeom xmlns:a="http://schemas.openxmlformats.org/drawingml/2006/main" prst="rect">
-            <a:avLst/>
-          </a:prstGeom>
-          <a:solidFill xmlns:a="http://schemas.openxmlformats.org/drawingml/2006/main">
-            <a:srgbClr val="F2F2F2"/>
-          </a:solidFill>
-          <a:ln xmlns:a="http://schemas.openxmlformats.org/drawingml/2006/main" w="0">
-            <a:solidFill>
-              <a:srgbClr val="F2F2F2"/>
-            </a:solidFill>
-            <a:prstDash val="solid"/>
-          </a:ln>
-        </p:spPr>
       </p:sp>
       <p:sp>
         <p:nvSpPr>
@@ -4000,8 +4015,8 @@
         </p:nvSpPr>
         <p:spPr>
           <a:xfrm xmlns:a="http://schemas.openxmlformats.org/drawingml/2006/main">
-            <a:off x="6572250" y="3076575"/>
-            <a:ext cx="4905375" cy="457200"/>
+            <a:off x="400050" y="2333625"/>
+            <a:ext cx="11391900" cy="419100"/>
           </a:xfrm>
           <a:prstGeom xmlns:a="http://schemas.openxmlformats.org/drawingml/2006/main" prst="rect">
             <a:avLst/>
@@ -4036,7 +4051,7 @@
                 <a:ea typeface="Helvetica Neue"/>
                 <a:cs typeface="Helvetica Neue"/>
               </a:rPr>
-              <a:t>Eligible t</a:t>
+              <a:t>Основные выводы</a:t>
             </a:r>
           </a:p>
         </p:txBody>
@@ -4057,8 +4072,8 @@
         </p:nvSpPr>
         <p:spPr>
           <a:xfrm xmlns:a="http://schemas.openxmlformats.org/drawingml/2006/main">
-            <a:off x="6572250" y="3609975"/>
-            <a:ext cx="4905375" cy="523875"/>
+            <a:off x="400050" y="2771775"/>
+            <a:ext cx="11391900" cy="1685925"/>
           </a:xfrm>
           <a:prstGeom xmlns:a="http://schemas.openxmlformats.org/drawingml/2006/main" prst="rect">
             <a:avLst/>
@@ -4093,43 +4108,82 @@
                 <a:ea typeface="Helvetica Neue"/>
                 <a:cs typeface="Helvetica Neue"/>
               </a:rPr>
-              <a:t>в знаменателе только счета, успевшие дожить до месяца t</a:t>
+              <a:t>• Текущая база из 100 000 активных клиентов приносит 45 млн руб. в месяц до расходов на новое привлечение: 100 000 × (1 000 − 500) − 5 млн.</a:t>
+            </a:r>
+          </a:p>
+          <a:p xmlns:a="http://schemas.openxmlformats.org/drawingml/2006/main">
+            <a:pPr>
+              <a:buNone/>
+              <a:defRPr sz="1500">
+                <a:solidFill>
+                  <a:srgbClr val="000000"/>
+                </a:solidFill>
+                <a:latin typeface="Helvetica Neue"/>
+                <a:ea typeface="Helvetica Neue"/>
+                <a:cs typeface="Helvetica Neue"/>
+              </a:defRPr>
+            </a:pPr>
+            <a:r>
+              <a:rPr sz="1500">
+                <a:solidFill>
+                  <a:srgbClr val="000000"/>
+                </a:solidFill>
+                <a:latin typeface="Helvetica Neue"/>
+                <a:ea typeface="Helvetica Neue"/>
+                <a:cs typeface="Helvetica Neue"/>
+              </a:rPr>
+              <a:t>• Следовательно, банк уже операционно прибылен при заданных вводных.</a:t>
+            </a:r>
+          </a:p>
+          <a:p xmlns:a="http://schemas.openxmlformats.org/drawingml/2006/main">
+            <a:pPr>
+              <a:buNone/>
+              <a:defRPr sz="1500">
+                <a:solidFill>
+                  <a:srgbClr val="000000"/>
+                </a:solidFill>
+                <a:latin typeface="Helvetica Neue"/>
+                <a:ea typeface="Helvetica Neue"/>
+                <a:cs typeface="Helvetica Neue"/>
+              </a:defRPr>
+            </a:pPr>
+            <a:r>
+              <a:rPr sz="1500">
+                <a:solidFill>
+                  <a:srgbClr val="000000"/>
+                </a:solidFill>
+                <a:latin typeface="Helvetica Neue"/>
+                <a:ea typeface="Helvetica Neue"/>
+                <a:cs typeface="Helvetica Neue"/>
+              </a:rPr>
+              <a:t>• При обслуживании только в активные месяцы и среднем остатке 0 руб. один привлечённый счёт даёт 2 367 руб. маржи после CAC на 29-месячном горизонте.</a:t>
+            </a:r>
+          </a:p>
+          <a:p xmlns:a="http://schemas.openxmlformats.org/drawingml/2006/main">
+            <a:pPr>
+              <a:buNone/>
+              <a:defRPr sz="1500">
+                <a:solidFill>
+                  <a:srgbClr val="000000"/>
+                </a:solidFill>
+                <a:latin typeface="Helvetica Neue"/>
+                <a:ea typeface="Helvetica Neue"/>
+                <a:cs typeface="Helvetica Neue"/>
+              </a:defRPr>
+            </a:pPr>
+            <a:r>
+              <a:rPr sz="1500">
+                <a:solidFill>
+                  <a:srgbClr val="000000"/>
+                </a:solidFill>
+                <a:latin typeface="Helvetica Neue"/>
+                <a:ea typeface="Helvetica Neue"/>
+                <a:cs typeface="Helvetica Neue"/>
+              </a:rPr>
+              <a:t>• Для покрытия постоянных расходов только новым потоком требуется 2 113 новых клиентов в месяц.</a:t>
             </a:r>
           </a:p>
         </p:txBody>
-      </p:sp>
-      <p:sp>
-        <p:nvSpPr>
-          <p:cNvPr id="9" name="slide2-panel-3">
-            <a:extLst xmlns:a="http://schemas.openxmlformats.org/drawingml/2006/main">
-              <a:ext uri="{FF2B5EF4-FFF2-40B4-BE49-F238E27FC236}">
-                <a16:creationId xmlns:a16="http://schemas.microsoft.com/office/drawing/2014/main" id="{CAA7C704-AE6E-42D6-B948-0D90C2ECDCCC}"/>
-              </a:ext>
-            </a:extLst>
-          </p:cNvPr>
-          <p:cNvSpPr>
-            <a:spLocks xmlns:a="http://schemas.openxmlformats.org/drawingml/2006/main" noGrp="1"/>
-          </p:cNvSpPr>
-          <p:nvPr/>
-        </p:nvSpPr>
-        <p:spPr>
-          <a:xfrm xmlns:a="http://schemas.openxmlformats.org/drawingml/2006/main">
-            <a:off x="6267450" y="4514850"/>
-            <a:ext cx="5534025" cy="1428750"/>
-          </a:xfrm>
-          <a:prstGeom xmlns:a="http://schemas.openxmlformats.org/drawingml/2006/main" prst="rect">
-            <a:avLst/>
-          </a:prstGeom>
-          <a:solidFill xmlns:a="http://schemas.openxmlformats.org/drawingml/2006/main">
-            <a:srgbClr val="F2F2F2"/>
-          </a:solidFill>
-          <a:ln xmlns:a="http://schemas.openxmlformats.org/drawingml/2006/main" w="0">
-            <a:solidFill>
-              <a:srgbClr val="F2F2F2"/>
-            </a:solidFill>
-            <a:prstDash val="solid"/>
-          </a:ln>
-        </p:spPr>
       </p:sp>
       <p:sp>
         <p:nvSpPr>
@@ -4147,8 +4201,8 @@
         </p:nvSpPr>
         <p:spPr>
           <a:xfrm xmlns:a="http://schemas.openxmlformats.org/drawingml/2006/main">
-            <a:off x="6572250" y="4733925"/>
-            <a:ext cx="4905375" cy="457200"/>
+            <a:off x="400050" y="4552950"/>
+            <a:ext cx="11391900" cy="419100"/>
           </a:xfrm>
           <a:prstGeom xmlns:a="http://schemas.openxmlformats.org/drawingml/2006/main" prst="rect">
             <a:avLst/>
@@ -4183,7 +4237,7 @@
                 <a:ea typeface="Helvetica Neue"/>
                 <a:cs typeface="Helvetica Neue"/>
               </a:rPr>
-              <a:t>LTV</a:t>
+              <a:t>Acquisition engine</a:t>
             </a:r>
           </a:p>
         </p:txBody>
@@ -4204,8 +4258,8 @@
         </p:nvSpPr>
         <p:spPr>
           <a:xfrm xmlns:a="http://schemas.openxmlformats.org/drawingml/2006/main">
-            <a:off x="6572250" y="5267325"/>
-            <a:ext cx="4905375" cy="523875"/>
+            <a:off x="400050" y="4991100"/>
+            <a:ext cx="11391900" cy="1181100"/>
           </a:xfrm>
           <a:prstGeom xmlns:a="http://schemas.openxmlformats.org/drawingml/2006/main" prst="rect">
             <a:avLst/>
@@ -4240,7 +4294,55 @@
                 <a:ea typeface="Helvetica Neue"/>
                 <a:cs typeface="Helvetica Neue"/>
               </a:rPr>
-              <a:t>комиссии + доход на остаток − сервис − CAC</a:t>
+              <a:t>• LTV до CAC без дохода на остаток — 7 367 руб.; CAC окупается за 18 месяцев.</a:t>
+            </a:r>
+          </a:p>
+          <a:p xmlns:a="http://schemas.openxmlformats.org/drawingml/2006/main">
+            <a:pPr>
+              <a:buNone/>
+              <a:defRPr sz="1500">
+                <a:solidFill>
+                  <a:srgbClr val="000000"/>
+                </a:solidFill>
+                <a:latin typeface="Helvetica Neue"/>
+                <a:ea typeface="Helvetica Neue"/>
+                <a:cs typeface="Helvetica Neue"/>
+              </a:defRPr>
+            </a:pPr>
+            <a:r>
+              <a:rPr sz="1500">
+                <a:solidFill>
+                  <a:srgbClr val="000000"/>
+                </a:solidFill>
+                <a:latin typeface="Helvetica Neue"/>
+                <a:ea typeface="Helvetica Neue"/>
+                <a:cs typeface="Helvetica Neue"/>
+              </a:rPr>
+              <a:t>• 122 клиента (0,61% выборки) открыли счёт повторно; обнаружено 125 повторных счетов.</a:t>
+            </a:r>
+          </a:p>
+          <a:p xmlns:a="http://schemas.openxmlformats.org/drawingml/2006/main">
+            <a:pPr>
+              <a:buNone/>
+              <a:defRPr sz="1500">
+                <a:solidFill>
+                  <a:srgbClr val="000000"/>
+                </a:solidFill>
+                <a:latin typeface="Helvetica Neue"/>
+                <a:ea typeface="Helvetica Neue"/>
+                <a:cs typeface="Helvetica Neue"/>
+              </a:defRPr>
+            </a:pPr>
+            <a:r>
+              <a:rPr sz="1500">
+                <a:solidFill>
+                  <a:srgbClr val="000000"/>
+                </a:solidFill>
+                <a:latin typeface="Helvetica Neue"/>
+                <a:ea typeface="Helvetica Neue"/>
+                <a:cs typeface="Helvetica Neue"/>
+              </a:rPr>
+              <a:t>• Состояние действующего банка и окупаемость привлечения — разные управленческие вопросы; в дашборде они показаны раздельно.</a:t>
             </a:r>
           </a:p>
         </p:txBody>
@@ -4297,7 +4399,7 @@
                 <a:ea typeface="Helvetica Neue"/>
                 <a:cs typeface="Helvetica Neue"/>
               </a:rPr>
-              <a:t>Источник: методология и формулы из README</a:t>
+              <a:t>Источник: README проекта</a:t>
             </a:r>
           </a:p>
         </p:txBody>
@@ -4440,7 +4542,7 @@
                 <a:ea typeface="Helvetica Neue"/>
                 <a:cs typeface="Helvetica Neue"/>
               </a:rPr>
-              <a:t>Ограничения и проверяемость</a:t>
+              <a:t>Ограничения</a:t>
             </a:r>
           </a:p>
         </p:txBody>
@@ -4452,48 +4554,15 @@
           <p:nvPr/>
         </p:nvGraphicFramePr>
         <p:xfrm>
-          <a:off xmlns:a="http://schemas.openxmlformats.org/drawingml/2006/main" x="381000" y="1200150"/>
-          <a:ext xmlns:a="http://schemas.openxmlformats.org/drawingml/2006/main" cx="5524500" cy="5000625"/>
+          <a:off xmlns:a="http://schemas.openxmlformats.org/drawingml/2006/main" x="-19050000" y="-19050000"/>
+          <a:ext xmlns:a="http://schemas.openxmlformats.org/drawingml/2006/main" cx="9525" cy="9525"/>
         </p:xfrm>
         <a:graphic xmlns:a="http://schemas.openxmlformats.org/drawingml/2006/main">
           <a:graphicData uri="http://schemas.openxmlformats.org/drawingml/2006/chart">
-            <c:chart xmlns:r="http://schemas.openxmlformats.org/officeDocument/2006/relationships" xmlns:c="http://schemas.openxmlformats.org/drawingml/2006/chart" r:id="Rf911a6cecf614712"/>
+            <c:chart xmlns:r="http://schemas.openxmlformats.org/officeDocument/2006/relationships" xmlns:c="http://schemas.openxmlformats.org/drawingml/2006/chart" r:id="R2603cd441a8f4679"/>
           </a:graphicData>
         </a:graphic>
       </p:graphicFrame>
-      <p:sp>
-        <p:nvSpPr>
-          <p:cNvPr id="3" name="slide2-panel-1">
-            <a:extLst xmlns:a="http://schemas.openxmlformats.org/drawingml/2006/main">
-              <a:ext uri="{FF2B5EF4-FFF2-40B4-BE49-F238E27FC236}">
-                <a16:creationId xmlns:a16="http://schemas.microsoft.com/office/drawing/2014/main" id="{71BE8BF3-4117-437F-A07F-9FDA57505565}"/>
-              </a:ext>
-            </a:extLst>
-          </p:cNvPr>
-          <p:cNvSpPr>
-            <a:spLocks xmlns:a="http://schemas.openxmlformats.org/drawingml/2006/main" noGrp="1"/>
-          </p:cNvSpPr>
-          <p:nvPr/>
-        </p:nvSpPr>
-        <p:spPr>
-          <a:xfrm xmlns:a="http://schemas.openxmlformats.org/drawingml/2006/main">
-            <a:off x="6267450" y="1200150"/>
-            <a:ext cx="5534025" cy="1428750"/>
-          </a:xfrm>
-          <a:prstGeom xmlns:a="http://schemas.openxmlformats.org/drawingml/2006/main" prst="rect">
-            <a:avLst/>
-          </a:prstGeom>
-          <a:solidFill xmlns:a="http://schemas.openxmlformats.org/drawingml/2006/main">
-            <a:srgbClr val="F2F2F2"/>
-          </a:solidFill>
-          <a:ln xmlns:a="http://schemas.openxmlformats.org/drawingml/2006/main" w="0">
-            <a:solidFill>
-              <a:srgbClr val="F2F2F2"/>
-            </a:solidFill>
-            <a:prstDash val="solid"/>
-          </a:ln>
-        </p:spPr>
-      </p:sp>
       <p:sp>
         <p:nvSpPr>
           <p:cNvPr id="4" name="slide2-stat-1">
@@ -4510,8 +4579,8 @@
         </p:nvSpPr>
         <p:spPr>
           <a:xfrm xmlns:a="http://schemas.openxmlformats.org/drawingml/2006/main">
-            <a:off x="6572250" y="1419225"/>
-            <a:ext cx="4905375" cy="457200"/>
+            <a:off x="400050" y="1219200"/>
+            <a:ext cx="11391900" cy="419100"/>
           </a:xfrm>
           <a:prstGeom xmlns:a="http://schemas.openxmlformats.org/drawingml/2006/main" prst="rect">
             <a:avLst/>
@@ -4546,7 +4615,7 @@
                 <a:ea typeface="Helvetica Neue"/>
                 <a:cs typeface="Helvetica Neue"/>
               </a:rPr>
-              <a:t>29 мес.</a:t>
+              <a:t>Горизонт наблюдения</a:t>
             </a:r>
           </a:p>
         </p:txBody>
@@ -4567,8 +4636,8 @@
         </p:nvSpPr>
         <p:spPr>
           <a:xfrm xmlns:a="http://schemas.openxmlformats.org/drawingml/2006/main">
-            <a:off x="6572250" y="1952625"/>
-            <a:ext cx="4905375" cy="523875"/>
+            <a:off x="400050" y="1676400"/>
+            <a:ext cx="11391900" cy="647700"/>
           </a:xfrm>
           <a:prstGeom xmlns:a="http://schemas.openxmlformats.org/drawingml/2006/main" prst="rect">
             <a:avLst/>
@@ -4603,43 +4672,10 @@
                 <a:ea typeface="Helvetica Neue"/>
                 <a:cs typeface="Helvetica Neue"/>
               </a:rPr>
-              <a:t>LTV усечён наблюдаемым горизонтом</a:t>
+              <a:t>LTV усечён фактически наблюдаемыми 29 месяцами и является консервативным для долгоживущих счетов.</a:t>
             </a:r>
           </a:p>
         </p:txBody>
-      </p:sp>
-      <p:sp>
-        <p:nvSpPr>
-          <p:cNvPr id="6" name="slide2-panel-2">
-            <a:extLst xmlns:a="http://schemas.openxmlformats.org/drawingml/2006/main">
-              <a:ext uri="{FF2B5EF4-FFF2-40B4-BE49-F238E27FC236}">
-                <a16:creationId xmlns:a16="http://schemas.microsoft.com/office/drawing/2014/main" id="{2967ABD8-699E-4E8D-88EB-E248FD0C86A2}"/>
-              </a:ext>
-            </a:extLst>
-          </p:cNvPr>
-          <p:cNvSpPr>
-            <a:spLocks xmlns:a="http://schemas.openxmlformats.org/drawingml/2006/main" noGrp="1"/>
-          </p:cNvSpPr>
-          <p:nvPr/>
-        </p:nvSpPr>
-        <p:spPr>
-          <a:xfrm xmlns:a="http://schemas.openxmlformats.org/drawingml/2006/main">
-            <a:off x="6267450" y="2857500"/>
-            <a:ext cx="5534025" cy="1428750"/>
-          </a:xfrm>
-          <a:prstGeom xmlns:a="http://schemas.openxmlformats.org/drawingml/2006/main" prst="rect">
-            <a:avLst/>
-          </a:prstGeom>
-          <a:solidFill xmlns:a="http://schemas.openxmlformats.org/drawingml/2006/main">
-            <a:srgbClr val="F2F2F2"/>
-          </a:solidFill>
-          <a:ln xmlns:a="http://schemas.openxmlformats.org/drawingml/2006/main" w="0">
-            <a:solidFill>
-              <a:srgbClr val="F2F2F2"/>
-            </a:solidFill>
-            <a:prstDash val="solid"/>
-          </a:ln>
-        </p:spPr>
       </p:sp>
       <p:sp>
         <p:nvSpPr>
@@ -4657,8 +4693,8 @@
         </p:nvSpPr>
         <p:spPr>
           <a:xfrm xmlns:a="http://schemas.openxmlformats.org/drawingml/2006/main">
-            <a:off x="6572250" y="3076575"/>
-            <a:ext cx="4905375" cy="457200"/>
+            <a:off x="400050" y="2667000"/>
+            <a:ext cx="11391900" cy="419100"/>
           </a:xfrm>
           <a:prstGeom xmlns:a="http://schemas.openxmlformats.org/drawingml/2006/main" prst="rect">
             <a:avLst/>
@@ -4693,7 +4729,7 @@
                 <a:ea typeface="Helvetica Neue"/>
                 <a:cs typeface="Helvetica Neue"/>
               </a:rPr>
-              <a:t>100 тыс.</a:t>
+              <a:t>Модельные допущения</a:t>
             </a:r>
           </a:p>
         </p:txBody>
@@ -4714,8 +4750,8 @@
         </p:nvSpPr>
         <p:spPr>
           <a:xfrm xmlns:a="http://schemas.openxmlformats.org/drawingml/2006/main">
-            <a:off x="6572250" y="3609975"/>
-            <a:ext cx="4905375" cy="523875"/>
+            <a:off x="400050" y="3124200"/>
+            <a:ext cx="11391900" cy="1009650"/>
           </a:xfrm>
           <a:prstGeom xmlns:a="http://schemas.openxmlformats.org/drawingml/2006/main" prst="rect">
             <a:avLst/>
@@ -4750,43 +4786,10 @@
                 <a:ea typeface="Helvetica Neue"/>
                 <a:cs typeface="Helvetica Neue"/>
               </a:rPr>
-              <a:t>денежные оценки масштабируются через текущую базу</a:t>
+              <a:t>Доход на остатки начисляется только в активные месяцы; это явное модельное допущение. Закрытие определяется как последний наблюдаемый месяц раньше мая 2026 года.</a:t>
             </a:r>
           </a:p>
         </p:txBody>
-      </p:sp>
-      <p:sp>
-        <p:nvSpPr>
-          <p:cNvPr id="9" name="slide2-panel-3">
-            <a:extLst xmlns:a="http://schemas.openxmlformats.org/drawingml/2006/main">
-              <a:ext uri="{FF2B5EF4-FFF2-40B4-BE49-F238E27FC236}">
-                <a16:creationId xmlns:a16="http://schemas.microsoft.com/office/drawing/2014/main" id="{CAA7C704-AE6E-42D6-B948-0D90C2ECDCCC}"/>
-              </a:ext>
-            </a:extLst>
-          </p:cNvPr>
-          <p:cNvSpPr>
-            <a:spLocks xmlns:a="http://schemas.openxmlformats.org/drawingml/2006/main" noGrp="1"/>
-          </p:cNvSpPr>
-          <p:nvPr/>
-        </p:nvSpPr>
-        <p:spPr>
-          <a:xfrm xmlns:a="http://schemas.openxmlformats.org/drawingml/2006/main">
-            <a:off x="6267450" y="4514850"/>
-            <a:ext cx="5534025" cy="1428750"/>
-          </a:xfrm>
-          <a:prstGeom xmlns:a="http://schemas.openxmlformats.org/drawingml/2006/main" prst="rect">
-            <a:avLst/>
-          </a:prstGeom>
-          <a:solidFill xmlns:a="http://schemas.openxmlformats.org/drawingml/2006/main">
-            <a:srgbClr val="F2F2F2"/>
-          </a:solidFill>
-          <a:ln xmlns:a="http://schemas.openxmlformats.org/drawingml/2006/main" w="0">
-            <a:solidFill>
-              <a:srgbClr val="F2F2F2"/>
-            </a:solidFill>
-            <a:prstDash val="solid"/>
-          </a:ln>
-        </p:spPr>
       </p:sp>
       <p:sp>
         <p:nvSpPr>
@@ -4804,8 +4807,8 @@
         </p:nvSpPr>
         <p:spPr>
           <a:xfrm xmlns:a="http://schemas.openxmlformats.org/drawingml/2006/main">
-            <a:off x="6572250" y="4733925"/>
-            <a:ext cx="4905375" cy="457200"/>
+            <a:off x="400050" y="4572000"/>
+            <a:ext cx="11391900" cy="419100"/>
           </a:xfrm>
           <a:prstGeom xmlns:a="http://schemas.openxmlformats.org/drawingml/2006/main" prst="rect">
             <a:avLst/>
@@ -4840,7 +4843,7 @@
                 <a:ea typeface="Helvetica Neue"/>
                 <a:cs typeface="Helvetica Neue"/>
               </a:rPr>
-              <a:t>config + tests</a:t>
+              <a:t>Масштабирование</a:t>
             </a:r>
           </a:p>
         </p:txBody>
@@ -4861,8 +4864,8 @@
         </p:nvSpPr>
         <p:spPr>
           <a:xfrm xmlns:a="http://schemas.openxmlformats.org/drawingml/2006/main">
-            <a:off x="6572250" y="5267325"/>
-            <a:ext cx="4905375" cy="523875"/>
+            <a:off x="400050" y="5029200"/>
+            <a:ext cx="11391900" cy="838200"/>
           </a:xfrm>
           <a:prstGeom xmlns:a="http://schemas.openxmlformats.org/drawingml/2006/main" prst="rect">
             <a:avLst/>
@@ -4897,7 +4900,7 @@
                 <a:ea typeface="Helvetica Neue"/>
                 <a:cs typeface="Helvetica Neue"/>
               </a:rPr>
-              <a:t>допущения вынесены отдельно, расчёты проверяются автоматически</a:t>
+              <a:t>Датасет является рандомизированной выборкой, поэтому денежные оценки масштабируются через предоставленную базу действующих клиентов, а не через 20 000 клиентов выборки.</a:t>
             </a:r>
           </a:p>
         </p:txBody>
@@ -4954,7 +4957,7 @@
                 <a:ea typeface="Helvetica Neue"/>
                 <a:cs typeface="Helvetica Neue"/>
               </a:rPr>
-              <a:t>Источник: ограничения и структура проекта из README</a:t>
+              <a:t>Источник: README проекта</a:t>
             </a:r>
           </a:p>
         </p:txBody>

</xml_diff>